<commit_message>
docs: archive the prototype; add final deploy records and deck
</commit_message>
<xml_diff>
--- a/witness-protocol-deck.pptx
+++ b/witness-protocol-deck.pptx
@@ -10,9 +10,11 @@
     <p:sldId id="258" r:id="rId4"/>
     <p:sldId id="259" r:id="rId5"/>
     <p:sldId id="260" r:id="rId6"/>
+    <p:sldId id="261" r:id="rId7"/>
+    <p:sldId id="262" r:id="rId8"/>
   </p:sldIdLst>
   <p:notesMasterIdLst>
-    <p:notesMasterId r:id="rId7"/>
+    <p:notesMasterId r:id="rId9"/>
   </p:notesMasterIdLst>
   <p:sldSz cx="9144000" cy="5143500"/>
   <p:notesSz cx="5143500" cy="9144000"/>
@@ -882,6 +884,182 @@
             <a:fld id="{F7021451-1387-4CA6-816F-3879F97B5CBC}" type="slidenum">
               <a:rPr lang="en-US"/>
               <a:t>5</a:t>
+            </a:fld>
+            <a:endParaRPr lang="en-US"/>
+          </a:p>
+        </p:txBody>
+      </p:sp>
+    </p:spTree>
+    <p:extLst>
+      <p:ext uri="{BB962C8B-B14F-4D97-AF65-F5344CB8AC3E}">
+        <p14:creationId xmlns:p14="http://schemas.microsoft.com/office/powerpoint/2010/main" val="1024086991"/>
+      </p:ext>
+    </p:extLst>
+  </p:cSld>
+  <p:clrMapOvr>
+    <a:masterClrMapping/>
+  </p:clrMapOvr>
+</p:notes>
+</file>
+
+<file path=ppt/notesSlides/notesSlide6.xml><?xml version="1.0" encoding="utf-8"?>
+<p:notes xmlns:a="http://schemas.openxmlformats.org/drawingml/2006/main" xmlns:r="http://schemas.openxmlformats.org/officeDocument/2006/relationships" xmlns:p="http://schemas.openxmlformats.org/presentationml/2006/main">
+  <p:cSld>
+    <p:spTree>
+      <p:nvGrpSpPr>
+        <p:cNvPr id="1" name=""/>
+        <p:cNvGrpSpPr/>
+        <p:nvPr/>
+      </p:nvGrpSpPr>
+      <p:grpSpPr>
+        <a:xfrm>
+          <a:off x="0" y="0"/>
+          <a:ext cx="0" cy="0"/>
+          <a:chOff x="0" y="0"/>
+          <a:chExt cx="0" cy="0"/>
+        </a:xfrm>
+      </p:grpSpPr>
+      <p:sp>
+        <p:nvSpPr>
+          <p:cNvPr id="2" name="Slide Image Placeholder 1"/>
+          <p:cNvSpPr>
+            <a:spLocks noGrp="1" noRot="1" noChangeAspect="1"/>
+          </p:cNvSpPr>
+          <p:nvPr>
+            <p:ph type="sldImg"/>
+          </p:nvPr>
+        </p:nvSpPr>
+        <p:spPr/>
+      </p:sp>
+      <p:sp>
+        <p:nvSpPr>
+          <p:cNvPr id="3" name="Notes Placeholder 2"/>
+          <p:cNvSpPr>
+            <a:spLocks noGrp="1"/>
+          </p:cNvSpPr>
+          <p:nvPr>
+            <p:ph type="body" idx="1"/>
+          </p:nvPr>
+        </p:nvSpPr>
+        <p:spPr/>
+        <p:txBody>
+          <a:bodyPr/>
+          <a:lstStyle/>
+          <a:p>
+            <a:r>
+              <a:rPr lang="en-US" dirty="0"/>
+              <a:t/>
+            </a:r>
+            <a:endParaRPr lang="en-US" dirty="0"/>
+          </a:p>
+        </p:txBody>
+      </p:sp>
+      <p:sp>
+        <p:nvSpPr>
+          <p:cNvPr id="4" name="Slide Number Placeholder 3"/>
+          <p:cNvSpPr>
+            <a:spLocks noGrp="1"/>
+          </p:cNvSpPr>
+          <p:nvPr>
+            <p:ph type="sldNum" sz="quarter" idx="10"/>
+          </p:nvPr>
+        </p:nvSpPr>
+        <p:spPr/>
+        <p:txBody>
+          <a:bodyPr/>
+          <a:lstStyle/>
+          <a:p>
+            <a:fld id="{F7021451-1387-4CA6-816F-3879F97B5CBC}" type="slidenum">
+              <a:rPr lang="en-US"/>
+              <a:t>6</a:t>
+            </a:fld>
+            <a:endParaRPr lang="en-US"/>
+          </a:p>
+        </p:txBody>
+      </p:sp>
+    </p:spTree>
+    <p:extLst>
+      <p:ext uri="{BB962C8B-B14F-4D97-AF65-F5344CB8AC3E}">
+        <p14:creationId xmlns:p14="http://schemas.microsoft.com/office/powerpoint/2010/main" val="1024086991"/>
+      </p:ext>
+    </p:extLst>
+  </p:cSld>
+  <p:clrMapOvr>
+    <a:masterClrMapping/>
+  </p:clrMapOvr>
+</p:notes>
+</file>
+
+<file path=ppt/notesSlides/notesSlide7.xml><?xml version="1.0" encoding="utf-8"?>
+<p:notes xmlns:a="http://schemas.openxmlformats.org/drawingml/2006/main" xmlns:r="http://schemas.openxmlformats.org/officeDocument/2006/relationships" xmlns:p="http://schemas.openxmlformats.org/presentationml/2006/main">
+  <p:cSld>
+    <p:spTree>
+      <p:nvGrpSpPr>
+        <p:cNvPr id="1" name=""/>
+        <p:cNvGrpSpPr/>
+        <p:nvPr/>
+      </p:nvGrpSpPr>
+      <p:grpSpPr>
+        <a:xfrm>
+          <a:off x="0" y="0"/>
+          <a:ext cx="0" cy="0"/>
+          <a:chOff x="0" y="0"/>
+          <a:chExt cx="0" cy="0"/>
+        </a:xfrm>
+      </p:grpSpPr>
+      <p:sp>
+        <p:nvSpPr>
+          <p:cNvPr id="2" name="Slide Image Placeholder 1"/>
+          <p:cNvSpPr>
+            <a:spLocks noGrp="1" noRot="1" noChangeAspect="1"/>
+          </p:cNvSpPr>
+          <p:nvPr>
+            <p:ph type="sldImg"/>
+          </p:nvPr>
+        </p:nvSpPr>
+        <p:spPr/>
+      </p:sp>
+      <p:sp>
+        <p:nvSpPr>
+          <p:cNvPr id="3" name="Notes Placeholder 2"/>
+          <p:cNvSpPr>
+            <a:spLocks noGrp="1"/>
+          </p:cNvSpPr>
+          <p:nvPr>
+            <p:ph type="body" idx="1"/>
+          </p:nvPr>
+        </p:nvSpPr>
+        <p:spPr/>
+        <p:txBody>
+          <a:bodyPr/>
+          <a:lstStyle/>
+          <a:p>
+            <a:r>
+              <a:rPr lang="en-US" dirty="0"/>
+              <a:t/>
+            </a:r>
+            <a:endParaRPr lang="en-US" dirty="0"/>
+          </a:p>
+        </p:txBody>
+      </p:sp>
+      <p:sp>
+        <p:nvSpPr>
+          <p:cNvPr id="4" name="Slide Number Placeholder 3"/>
+          <p:cNvSpPr>
+            <a:spLocks noGrp="1"/>
+          </p:cNvSpPr>
+          <p:nvPr>
+            <p:ph type="sldNum" sz="quarter" idx="10"/>
+          </p:nvPr>
+        </p:nvSpPr>
+        <p:spPr/>
+        <p:txBody>
+          <a:bodyPr/>
+          <a:lstStyle/>
+          <a:p>
+            <a:fld id="{F7021451-1387-4CA6-816F-3879F97B5CBC}" type="slidenum">
+              <a:rPr lang="en-US"/>
+              <a:t>7</a:t>
             </a:fld>
             <a:endParaRPr lang="en-US"/>
           </a:p>
@@ -3186,6 +3364,3449 @@
 </p:sld>
 </file>
 
+<file path=ppt/slides/slide6.xml><?xml version="1.0" encoding="utf-8"?>
+<p:sld xmlns:a="http://schemas.openxmlformats.org/drawingml/2006/main" xmlns:r="http://schemas.openxmlformats.org/officeDocument/2006/relationships" xmlns:p="http://schemas.openxmlformats.org/presentationml/2006/main">
+  <p:cSld name="Slide 6">
+    <p:bg>
+      <p:bgPr>
+        <a:solidFill>
+          <a:srgbClr val="0F172A"/>
+        </a:solidFill>
+      </p:bgPr>
+    </p:bg>
+    <p:spTree>
+      <p:nvGrpSpPr>
+        <p:cNvPr id="1" name=""/>
+        <p:cNvGrpSpPr/>
+        <p:nvPr/>
+      </p:nvGrpSpPr>
+      <p:grpSpPr>
+        <a:xfrm>
+          <a:off x="0" y="0"/>
+          <a:ext cx="0" cy="0"/>
+          <a:chOff x="0" y="0"/>
+          <a:chExt cx="0" cy="0"/>
+        </a:xfrm>
+      </p:grpSpPr>
+      <p:sp>
+        <p:nvSpPr>
+          <p:cNvPr id="2" name="Text 0"/>
+          <p:cNvSpPr/>
+          <p:nvPr/>
+        </p:nvSpPr>
+        <p:spPr>
+          <a:xfrm>
+            <a:off x="457200" y="274320"/>
+            <a:ext cx="8229600" cy="457200"/>
+          </a:xfrm>
+          <a:prstGeom prst="rect">
+            <a:avLst/>
+          </a:prstGeom>
+          <a:noFill/>
+          <a:ln/>
+        </p:spPr>
+        <p:txBody>
+          <a:bodyPr wrap="square" lIns="0" tIns="0" rIns="0" bIns="0" rtlCol="0" anchor="ctr"/>
+          <a:lstStyle/>
+          <a:p>
+            <a:pPr algn="ctr" indent="0" marL="0">
+              <a:buNone/>
+            </a:pPr>
+            <a:r>
+              <a:rPr lang="en-US" sz="2800" b="1" dirty="0">
+                <a:solidFill>
+                  <a:srgbClr val="FFFFFF"/>
+                </a:solidFill>
+                <a:latin typeface="Arial Black" pitchFamily="34" charset="0"/>
+                <a:ea typeface="Arial Black" pitchFamily="34" charset="-122"/>
+                <a:cs typeface="Arial Black" pitchFamily="34" charset="-120"/>
+              </a:rPr>
+              <a:t>Current Architecture</a:t>
+            </a:r>
+            <a:endParaRPr lang="en-US" sz="2800" dirty="0"/>
+          </a:p>
+        </p:txBody>
+      </p:sp>
+      <p:sp>
+        <p:nvSpPr>
+          <p:cNvPr id="3" name="Text 1"/>
+          <p:cNvSpPr/>
+          <p:nvPr/>
+        </p:nvSpPr>
+        <p:spPr>
+          <a:xfrm>
+            <a:off x="457200" y="685800"/>
+            <a:ext cx="8229600" cy="274320"/>
+          </a:xfrm>
+          <a:prstGeom prst="rect">
+            <a:avLst/>
+          </a:prstGeom>
+          <a:noFill/>
+          <a:ln/>
+        </p:spPr>
+        <p:txBody>
+          <a:bodyPr wrap="square" lIns="0" tIns="0" rIns="0" bIns="0" rtlCol="0" anchor="ctr"/>
+          <a:lstStyle/>
+          <a:p>
+            <a:pPr algn="ctr" indent="0" marL="0">
+              <a:buNone/>
+            </a:pPr>
+            <a:r>
+              <a:rPr lang="en-US" sz="1400" dirty="0">
+                <a:solidFill>
+                  <a:srgbClr val="94A3B8"/>
+                </a:solidFill>
+                <a:latin typeface="Arial" pitchFamily="34" charset="0"/>
+                <a:ea typeface="Arial" pitchFamily="34" charset="-122"/>
+                <a:cs typeface="Arial" pitchFamily="34" charset="-120"/>
+              </a:rPr>
+              <a:t>Direct P2P Flow</a:t>
+            </a:r>
+            <a:endParaRPr lang="en-US" sz="1400" dirty="0"/>
+          </a:p>
+        </p:txBody>
+      </p:sp>
+      <p:sp>
+        <p:nvSpPr>
+          <p:cNvPr id="4" name="Shape 2"/>
+          <p:cNvSpPr/>
+          <p:nvPr/>
+        </p:nvSpPr>
+        <p:spPr>
+          <a:xfrm>
+            <a:off x="365760" y="1051560"/>
+            <a:ext cx="3840480" cy="1463040"/>
+          </a:xfrm>
+          <a:prstGeom prst="rect">
+            <a:avLst/>
+          </a:prstGeom>
+          <a:solidFill>
+            <a:srgbClr val="1E293B"/>
+          </a:solidFill>
+          <a:ln w="25400">
+            <a:solidFill>
+              <a:srgbClr val="06B6D4"/>
+            </a:solidFill>
+            <a:prstDash val="solid"/>
+          </a:ln>
+        </p:spPr>
+      </p:sp>
+      <p:sp>
+        <p:nvSpPr>
+          <p:cNvPr id="5" name="Text 3"/>
+          <p:cNvSpPr/>
+          <p:nvPr/>
+        </p:nvSpPr>
+        <p:spPr>
+          <a:xfrm>
+            <a:off x="457200" y="1097280"/>
+            <a:ext cx="3657600" cy="320040"/>
+          </a:xfrm>
+          <a:prstGeom prst="rect">
+            <a:avLst/>
+          </a:prstGeom>
+          <a:noFill/>
+          <a:ln/>
+        </p:spPr>
+        <p:txBody>
+          <a:bodyPr wrap="square" lIns="0" tIns="0" rIns="0" bIns="0" rtlCol="0" anchor="ctr"/>
+          <a:lstStyle/>
+          <a:p>
+            <a:pPr algn="l" indent="0" marL="0">
+              <a:buNone/>
+            </a:pPr>
+            <a:r>
+              <a:rPr lang="en-US" sz="1200" b="1" dirty="0">
+                <a:solidFill>
+                  <a:srgbClr val="06B6D4"/>
+                </a:solidFill>
+                <a:latin typeface="Arial" pitchFamily="34" charset="0"/>
+                <a:ea typeface="Arial" pitchFamily="34" charset="-122"/>
+                <a:cs typeface="Arial" pitchFamily="34" charset="-120"/>
+              </a:rPr>
+              <a:t>📱 User's Phone (PWA)</a:t>
+            </a:r>
+            <a:endParaRPr lang="en-US" sz="1200" dirty="0"/>
+          </a:p>
+        </p:txBody>
+      </p:sp>
+      <p:sp>
+        <p:nvSpPr>
+          <p:cNvPr id="6" name="Shape 4"/>
+          <p:cNvSpPr/>
+          <p:nvPr/>
+        </p:nvSpPr>
+        <p:spPr>
+          <a:xfrm>
+            <a:off x="502920" y="1508760"/>
+            <a:ext cx="777240" cy="411480"/>
+          </a:xfrm>
+          <a:prstGeom prst="rect">
+            <a:avLst/>
+          </a:prstGeom>
+          <a:solidFill>
+            <a:srgbClr val="0F172A"/>
+          </a:solidFill>
+          <a:ln w="12700">
+            <a:solidFill>
+              <a:srgbClr val="0891B2"/>
+            </a:solidFill>
+            <a:prstDash val="solid"/>
+          </a:ln>
+        </p:spPr>
+      </p:sp>
+      <p:sp>
+        <p:nvSpPr>
+          <p:cNvPr id="7" name="Text 5"/>
+          <p:cNvSpPr/>
+          <p:nvPr/>
+        </p:nvSpPr>
+        <p:spPr>
+          <a:xfrm>
+            <a:off x="502920" y="1554480"/>
+            <a:ext cx="777240" cy="320040"/>
+          </a:xfrm>
+          <a:prstGeom prst="rect">
+            <a:avLst/>
+          </a:prstGeom>
+          <a:noFill/>
+          <a:ln/>
+        </p:spPr>
+        <p:txBody>
+          <a:bodyPr wrap="square" lIns="0" tIns="0" rIns="0" bIns="0" rtlCol="0" anchor="ctr"/>
+          <a:lstStyle/>
+          <a:p>
+            <a:pPr algn="ctr" indent="0" marL="0">
+              <a:buNone/>
+            </a:pPr>
+            <a:r>
+              <a:rPr lang="en-US" sz="900" b="1" dirty="0">
+                <a:solidFill>
+                  <a:srgbClr val="FFFFFF"/>
+                </a:solidFill>
+                <a:latin typeface="Arial" pitchFamily="34" charset="0"/>
+                <a:ea typeface="Arial" pitchFamily="34" charset="-122"/>
+                <a:cs typeface="Arial" pitchFamily="34" charset="-120"/>
+              </a:rPr>
+              <a:t>Capture</a:t>
+            </a:r>
+            <a:endParaRPr lang="en-US" sz="900" dirty="0"/>
+          </a:p>
+        </p:txBody>
+      </p:sp>
+      <p:sp>
+        <p:nvSpPr>
+          <p:cNvPr id="8" name="Text 6"/>
+          <p:cNvSpPr/>
+          <p:nvPr/>
+        </p:nvSpPr>
+        <p:spPr>
+          <a:xfrm>
+            <a:off x="1234440" y="1572768"/>
+            <a:ext cx="228600" cy="274320"/>
+          </a:xfrm>
+          <a:prstGeom prst="rect">
+            <a:avLst/>
+          </a:prstGeom>
+          <a:noFill/>
+          <a:ln/>
+        </p:spPr>
+        <p:txBody>
+          <a:bodyPr wrap="square" lIns="0" tIns="0" rIns="0" bIns="0" rtlCol="0" anchor="ctr"/>
+          <a:lstStyle/>
+          <a:p>
+            <a:pPr algn="ctr" indent="0" marL="0">
+              <a:buNone/>
+            </a:pPr>
+            <a:r>
+              <a:rPr lang="en-US" sz="1200" dirty="0">
+                <a:solidFill>
+                  <a:srgbClr val="06B6D4"/>
+                </a:solidFill>
+                <a:latin typeface="Arial" pitchFamily="34" charset="0"/>
+                <a:ea typeface="Arial" pitchFamily="34" charset="-122"/>
+                <a:cs typeface="Arial" pitchFamily="34" charset="-120"/>
+              </a:rPr>
+              <a:t>→</a:t>
+            </a:r>
+            <a:endParaRPr lang="en-US" sz="1200" dirty="0"/>
+          </a:p>
+        </p:txBody>
+      </p:sp>
+      <p:sp>
+        <p:nvSpPr>
+          <p:cNvPr id="9" name="Shape 7"/>
+          <p:cNvSpPr/>
+          <p:nvPr/>
+        </p:nvSpPr>
+        <p:spPr>
+          <a:xfrm>
+            <a:off x="1417320" y="1508760"/>
+            <a:ext cx="777240" cy="411480"/>
+          </a:xfrm>
+          <a:prstGeom prst="rect">
+            <a:avLst/>
+          </a:prstGeom>
+          <a:solidFill>
+            <a:srgbClr val="0F172A"/>
+          </a:solidFill>
+          <a:ln w="12700">
+            <a:solidFill>
+              <a:srgbClr val="0891B2"/>
+            </a:solidFill>
+            <a:prstDash val="solid"/>
+          </a:ln>
+        </p:spPr>
+      </p:sp>
+      <p:sp>
+        <p:nvSpPr>
+          <p:cNvPr id="10" name="Text 8"/>
+          <p:cNvSpPr/>
+          <p:nvPr/>
+        </p:nvSpPr>
+        <p:spPr>
+          <a:xfrm>
+            <a:off x="1417320" y="1554480"/>
+            <a:ext cx="777240" cy="320040"/>
+          </a:xfrm>
+          <a:prstGeom prst="rect">
+            <a:avLst/>
+          </a:prstGeom>
+          <a:noFill/>
+          <a:ln/>
+        </p:spPr>
+        <p:txBody>
+          <a:bodyPr wrap="square" lIns="0" tIns="0" rIns="0" bIns="0" rtlCol="0" anchor="ctr"/>
+          <a:lstStyle/>
+          <a:p>
+            <a:pPr algn="ctr" indent="0" marL="0">
+              <a:buNone/>
+            </a:pPr>
+            <a:r>
+              <a:rPr lang="en-US" sz="900" b="1" dirty="0">
+                <a:solidFill>
+                  <a:srgbClr val="FFFFFF"/>
+                </a:solidFill>
+                <a:latin typeface="Arial" pitchFamily="34" charset="0"/>
+                <a:ea typeface="Arial" pitchFamily="34" charset="-122"/>
+                <a:cs typeface="Arial" pitchFamily="34" charset="-120"/>
+              </a:rPr>
+              <a:t>Encrypt</a:t>
+            </a:r>
+            <a:endParaRPr lang="en-US" sz="900" dirty="0"/>
+          </a:p>
+        </p:txBody>
+      </p:sp>
+      <p:sp>
+        <p:nvSpPr>
+          <p:cNvPr id="11" name="Text 9"/>
+          <p:cNvSpPr/>
+          <p:nvPr/>
+        </p:nvSpPr>
+        <p:spPr>
+          <a:xfrm>
+            <a:off x="2148840" y="1572768"/>
+            <a:ext cx="228600" cy="274320"/>
+          </a:xfrm>
+          <a:prstGeom prst="rect">
+            <a:avLst/>
+          </a:prstGeom>
+          <a:noFill/>
+          <a:ln/>
+        </p:spPr>
+        <p:txBody>
+          <a:bodyPr wrap="square" lIns="0" tIns="0" rIns="0" bIns="0" rtlCol="0" anchor="ctr"/>
+          <a:lstStyle/>
+          <a:p>
+            <a:pPr algn="ctr" indent="0" marL="0">
+              <a:buNone/>
+            </a:pPr>
+            <a:r>
+              <a:rPr lang="en-US" sz="1200" dirty="0">
+                <a:solidFill>
+                  <a:srgbClr val="06B6D4"/>
+                </a:solidFill>
+                <a:latin typeface="Arial" pitchFamily="34" charset="0"/>
+                <a:ea typeface="Arial" pitchFamily="34" charset="-122"/>
+                <a:cs typeface="Arial" pitchFamily="34" charset="-120"/>
+              </a:rPr>
+              <a:t>→</a:t>
+            </a:r>
+            <a:endParaRPr lang="en-US" sz="1200" dirty="0"/>
+          </a:p>
+        </p:txBody>
+      </p:sp>
+      <p:sp>
+        <p:nvSpPr>
+          <p:cNvPr id="12" name="Shape 10"/>
+          <p:cNvSpPr/>
+          <p:nvPr/>
+        </p:nvSpPr>
+        <p:spPr>
+          <a:xfrm>
+            <a:off x="2331720" y="1508760"/>
+            <a:ext cx="777240" cy="411480"/>
+          </a:xfrm>
+          <a:prstGeom prst="rect">
+            <a:avLst/>
+          </a:prstGeom>
+          <a:solidFill>
+            <a:srgbClr val="0F172A"/>
+          </a:solidFill>
+          <a:ln w="12700">
+            <a:solidFill>
+              <a:srgbClr val="0891B2"/>
+            </a:solidFill>
+            <a:prstDash val="solid"/>
+          </a:ln>
+        </p:spPr>
+      </p:sp>
+      <p:sp>
+        <p:nvSpPr>
+          <p:cNvPr id="13" name="Text 11"/>
+          <p:cNvSpPr/>
+          <p:nvPr/>
+        </p:nvSpPr>
+        <p:spPr>
+          <a:xfrm>
+            <a:off x="2331720" y="1554480"/>
+            <a:ext cx="777240" cy="320040"/>
+          </a:xfrm>
+          <a:prstGeom prst="rect">
+            <a:avLst/>
+          </a:prstGeom>
+          <a:noFill/>
+          <a:ln/>
+        </p:spPr>
+        <p:txBody>
+          <a:bodyPr wrap="square" lIns="0" tIns="0" rIns="0" bIns="0" rtlCol="0" anchor="ctr"/>
+          <a:lstStyle/>
+          <a:p>
+            <a:pPr algn="ctr" indent="0" marL="0">
+              <a:buNone/>
+            </a:pPr>
+            <a:r>
+              <a:rPr lang="en-US" sz="900" b="1" dirty="0">
+                <a:solidFill>
+                  <a:srgbClr val="FFFFFF"/>
+                </a:solidFill>
+                <a:latin typeface="Arial" pitchFamily="34" charset="0"/>
+                <a:ea typeface="Arial" pitchFamily="34" charset="-122"/>
+                <a:cs typeface="Arial" pitchFamily="34" charset="-120"/>
+              </a:rPr>
+              <a:t>Chunk</a:t>
+            </a:r>
+            <a:endParaRPr lang="en-US" sz="900" dirty="0"/>
+          </a:p>
+        </p:txBody>
+      </p:sp>
+      <p:sp>
+        <p:nvSpPr>
+          <p:cNvPr id="14" name="Text 12"/>
+          <p:cNvSpPr/>
+          <p:nvPr/>
+        </p:nvSpPr>
+        <p:spPr>
+          <a:xfrm>
+            <a:off x="3063240" y="1572768"/>
+            <a:ext cx="228600" cy="274320"/>
+          </a:xfrm>
+          <a:prstGeom prst="rect">
+            <a:avLst/>
+          </a:prstGeom>
+          <a:noFill/>
+          <a:ln/>
+        </p:spPr>
+        <p:txBody>
+          <a:bodyPr wrap="square" lIns="0" tIns="0" rIns="0" bIns="0" rtlCol="0" anchor="ctr"/>
+          <a:lstStyle/>
+          <a:p>
+            <a:pPr algn="ctr" indent="0" marL="0">
+              <a:buNone/>
+            </a:pPr>
+            <a:r>
+              <a:rPr lang="en-US" sz="1200" dirty="0">
+                <a:solidFill>
+                  <a:srgbClr val="06B6D4"/>
+                </a:solidFill>
+                <a:latin typeface="Arial" pitchFamily="34" charset="0"/>
+                <a:ea typeface="Arial" pitchFamily="34" charset="-122"/>
+                <a:cs typeface="Arial" pitchFamily="34" charset="-120"/>
+              </a:rPr>
+              <a:t>→</a:t>
+            </a:r>
+            <a:endParaRPr lang="en-US" sz="1200" dirty="0"/>
+          </a:p>
+        </p:txBody>
+      </p:sp>
+      <p:sp>
+        <p:nvSpPr>
+          <p:cNvPr id="15" name="Shape 13"/>
+          <p:cNvSpPr/>
+          <p:nvPr/>
+        </p:nvSpPr>
+        <p:spPr>
+          <a:xfrm>
+            <a:off x="3246120" y="1508760"/>
+            <a:ext cx="777240" cy="411480"/>
+          </a:xfrm>
+          <a:prstGeom prst="rect">
+            <a:avLst/>
+          </a:prstGeom>
+          <a:solidFill>
+            <a:srgbClr val="0F172A"/>
+          </a:solidFill>
+          <a:ln w="12700">
+            <a:solidFill>
+              <a:srgbClr val="0891B2"/>
+            </a:solidFill>
+            <a:prstDash val="solid"/>
+          </a:ln>
+        </p:spPr>
+      </p:sp>
+      <p:sp>
+        <p:nvSpPr>
+          <p:cNvPr id="16" name="Text 14"/>
+          <p:cNvSpPr/>
+          <p:nvPr/>
+        </p:nvSpPr>
+        <p:spPr>
+          <a:xfrm>
+            <a:off x="3246120" y="1554480"/>
+            <a:ext cx="777240" cy="320040"/>
+          </a:xfrm>
+          <a:prstGeom prst="rect">
+            <a:avLst/>
+          </a:prstGeom>
+          <a:noFill/>
+          <a:ln/>
+        </p:spPr>
+        <p:txBody>
+          <a:bodyPr wrap="square" lIns="0" tIns="0" rIns="0" bIns="0" rtlCol="0" anchor="ctr"/>
+          <a:lstStyle/>
+          <a:p>
+            <a:pPr algn="ctr" indent="0" marL="0">
+              <a:buNone/>
+            </a:pPr>
+            <a:r>
+              <a:rPr lang="en-US" sz="900" b="1" dirty="0">
+                <a:solidFill>
+                  <a:srgbClr val="FFFFFF"/>
+                </a:solidFill>
+                <a:latin typeface="Arial" pitchFamily="34" charset="0"/>
+                <a:ea typeface="Arial" pitchFamily="34" charset="-122"/>
+                <a:cs typeface="Arial" pitchFamily="34" charset="-120"/>
+              </a:rPr>
+              <a:t>Upload</a:t>
+            </a:r>
+            <a:endParaRPr lang="en-US" sz="900" dirty="0"/>
+          </a:p>
+        </p:txBody>
+      </p:sp>
+      <p:sp>
+        <p:nvSpPr>
+          <p:cNvPr id="17" name="Shape 15"/>
+          <p:cNvSpPr/>
+          <p:nvPr/>
+        </p:nvSpPr>
+        <p:spPr>
+          <a:xfrm>
+            <a:off x="502920" y="2057400"/>
+            <a:ext cx="1371600" cy="365760"/>
+          </a:xfrm>
+          <a:prstGeom prst="rect">
+            <a:avLst/>
+          </a:prstGeom>
+          <a:solidFill>
+            <a:srgbClr val="7C3AED"/>
+          </a:solidFill>
+          <a:ln w="12700">
+            <a:solidFill>
+              <a:srgbClr val="7C3AED"/>
+            </a:solidFill>
+            <a:prstDash val="solid"/>
+          </a:ln>
+        </p:spPr>
+      </p:sp>
+      <p:sp>
+        <p:nvSpPr>
+          <p:cNvPr id="18" name="Text 16"/>
+          <p:cNvSpPr/>
+          <p:nvPr/>
+        </p:nvSpPr>
+        <p:spPr>
+          <a:xfrm>
+            <a:off x="502920" y="2084832"/>
+            <a:ext cx="1371600" cy="320040"/>
+          </a:xfrm>
+          <a:prstGeom prst="rect">
+            <a:avLst/>
+          </a:prstGeom>
+          <a:noFill/>
+          <a:ln/>
+        </p:spPr>
+        <p:txBody>
+          <a:bodyPr wrap="square" lIns="0" tIns="0" rIns="0" bIns="0" rtlCol="0" anchor="ctr"/>
+          <a:lstStyle/>
+          <a:p>
+            <a:pPr algn="ctr" indent="0" marL="0">
+              <a:buNone/>
+            </a:pPr>
+            <a:r>
+              <a:rPr lang="en-US" sz="900" b="1" dirty="0">
+                <a:solidFill>
+                  <a:srgbClr val="FFFFFF"/>
+                </a:solidFill>
+                <a:latin typeface="Arial" pitchFamily="34" charset="0"/>
+                <a:ea typeface="Arial" pitchFamily="34" charset="-122"/>
+                <a:cs typeface="Arial" pitchFamily="34" charset="-120"/>
+              </a:rPr>
+              <a:t>Privy Auth</a:t>
+            </a:r>
+            <a:endParaRPr lang="en-US" sz="900" dirty="0"/>
+          </a:p>
+        </p:txBody>
+      </p:sp>
+      <p:sp>
+        <p:nvSpPr>
+          <p:cNvPr id="19" name="Text 17"/>
+          <p:cNvSpPr/>
+          <p:nvPr/>
+        </p:nvSpPr>
+        <p:spPr>
+          <a:xfrm>
+            <a:off x="1920240" y="2084832"/>
+            <a:ext cx="1828800" cy="320040"/>
+          </a:xfrm>
+          <a:prstGeom prst="rect">
+            <a:avLst/>
+          </a:prstGeom>
+          <a:noFill/>
+          <a:ln/>
+        </p:spPr>
+        <p:txBody>
+          <a:bodyPr wrap="square" lIns="0" tIns="0" rIns="0" bIns="0" rtlCol="0" anchor="ctr"/>
+          <a:lstStyle/>
+          <a:p>
+            <a:pPr algn="l" indent="0" marL="0">
+              <a:buNone/>
+            </a:pPr>
+            <a:r>
+              <a:rPr lang="en-US" sz="900" dirty="0">
+                <a:solidFill>
+                  <a:srgbClr val="CBD5E1"/>
+                </a:solidFill>
+                <a:latin typeface="Arial" pitchFamily="34" charset="0"/>
+                <a:ea typeface="Arial" pitchFamily="34" charset="-122"/>
+                <a:cs typeface="Arial" pitchFamily="34" charset="-120"/>
+              </a:rPr>
+              <a:t>→ Wallet → Keys</a:t>
+            </a:r>
+            <a:endParaRPr lang="en-US" sz="900" dirty="0"/>
+          </a:p>
+        </p:txBody>
+      </p:sp>
+      <p:sp>
+        <p:nvSpPr>
+          <p:cNvPr id="20" name="Shape 18"/>
+          <p:cNvSpPr/>
+          <p:nvPr/>
+        </p:nvSpPr>
+        <p:spPr>
+          <a:xfrm>
+            <a:off x="4754880" y="1051560"/>
+            <a:ext cx="4023360" cy="2286000"/>
+          </a:xfrm>
+          <a:prstGeom prst="rect">
+            <a:avLst/>
+          </a:prstGeom>
+          <a:solidFill>
+            <a:srgbClr val="1E293B"/>
+          </a:solidFill>
+          <a:ln w="12700">
+            <a:solidFill>
+              <a:srgbClr val="0891B2"/>
+            </a:solidFill>
+            <a:prstDash val="solid"/>
+          </a:ln>
+        </p:spPr>
+      </p:sp>
+      <p:sp>
+        <p:nvSpPr>
+          <p:cNvPr id="21" name="Text 19"/>
+          <p:cNvSpPr/>
+          <p:nvPr/>
+        </p:nvSpPr>
+        <p:spPr>
+          <a:xfrm>
+            <a:off x="4846320" y="1097280"/>
+            <a:ext cx="3840480" cy="320040"/>
+          </a:xfrm>
+          <a:prstGeom prst="rect">
+            <a:avLst/>
+          </a:prstGeom>
+          <a:noFill/>
+          <a:ln/>
+        </p:spPr>
+        <p:txBody>
+          <a:bodyPr wrap="square" lIns="0" tIns="0" rIns="0" bIns="0" rtlCol="0" anchor="ctr"/>
+          <a:lstStyle/>
+          <a:p>
+            <a:pPr algn="l" indent="0" marL="0">
+              <a:buNone/>
+            </a:pPr>
+            <a:r>
+              <a:rPr lang="en-US" sz="1200" b="1" dirty="0">
+                <a:solidFill>
+                  <a:srgbClr val="22D3EE"/>
+                </a:solidFill>
+                <a:latin typeface="Arial" pitchFamily="34" charset="0"/>
+                <a:ea typeface="Arial" pitchFamily="34" charset="-122"/>
+                <a:cs typeface="Arial" pitchFamily="34" charset="-120"/>
+              </a:rPr>
+              <a:t>☁️ Decentralized Layer</a:t>
+            </a:r>
+            <a:endParaRPr lang="en-US" sz="1200" dirty="0"/>
+          </a:p>
+        </p:txBody>
+      </p:sp>
+      <p:sp>
+        <p:nvSpPr>
+          <p:cNvPr id="22" name="Shape 20"/>
+          <p:cNvSpPr/>
+          <p:nvPr/>
+        </p:nvSpPr>
+        <p:spPr>
+          <a:xfrm>
+            <a:off x="4937760" y="1508760"/>
+            <a:ext cx="1645920" cy="640080"/>
+          </a:xfrm>
+          <a:prstGeom prst="rect">
+            <a:avLst/>
+          </a:prstGeom>
+          <a:solidFill>
+            <a:srgbClr val="065A82"/>
+          </a:solidFill>
+          <a:ln w="12700">
+            <a:solidFill>
+              <a:srgbClr val="065A82"/>
+            </a:solidFill>
+            <a:prstDash val="solid"/>
+          </a:ln>
+        </p:spPr>
+      </p:sp>
+      <p:sp>
+        <p:nvSpPr>
+          <p:cNvPr id="23" name="Text 21"/>
+          <p:cNvSpPr/>
+          <p:nvPr/>
+        </p:nvSpPr>
+        <p:spPr>
+          <a:xfrm>
+            <a:off x="4937760" y="1572768"/>
+            <a:ext cx="1645920" cy="228600"/>
+          </a:xfrm>
+          <a:prstGeom prst="rect">
+            <a:avLst/>
+          </a:prstGeom>
+          <a:noFill/>
+          <a:ln/>
+        </p:spPr>
+        <p:txBody>
+          <a:bodyPr wrap="square" lIns="0" tIns="0" rIns="0" bIns="0" rtlCol="0" anchor="ctr"/>
+          <a:lstStyle/>
+          <a:p>
+            <a:pPr algn="ctr" indent="0" marL="0">
+              <a:buNone/>
+            </a:pPr>
+            <a:r>
+              <a:rPr lang="en-US" sz="1000" b="1" dirty="0">
+                <a:solidFill>
+                  <a:srgbClr val="FFFFFF"/>
+                </a:solidFill>
+                <a:latin typeface="Arial" pitchFamily="34" charset="0"/>
+                <a:ea typeface="Arial" pitchFamily="34" charset="-122"/>
+                <a:cs typeface="Arial" pitchFamily="34" charset="-120"/>
+              </a:rPr>
+              <a:t>IPFS + Pinata</a:t>
+            </a:r>
+            <a:endParaRPr lang="en-US" sz="1000" dirty="0"/>
+          </a:p>
+        </p:txBody>
+      </p:sp>
+      <p:sp>
+        <p:nvSpPr>
+          <p:cNvPr id="24" name="Text 22"/>
+          <p:cNvSpPr/>
+          <p:nvPr/>
+        </p:nvSpPr>
+        <p:spPr>
+          <a:xfrm>
+            <a:off x="4937760" y="1801368"/>
+            <a:ext cx="1645920" cy="228600"/>
+          </a:xfrm>
+          <a:prstGeom prst="rect">
+            <a:avLst/>
+          </a:prstGeom>
+          <a:noFill/>
+          <a:ln/>
+        </p:spPr>
+        <p:txBody>
+          <a:bodyPr wrap="square" lIns="0" tIns="0" rIns="0" bIns="0" rtlCol="0" anchor="ctr"/>
+          <a:lstStyle/>
+          <a:p>
+            <a:pPr algn="ctr" indent="0" marL="0">
+              <a:buNone/>
+            </a:pPr>
+            <a:r>
+              <a:rPr lang="en-US" sz="800" dirty="0">
+                <a:solidFill>
+                  <a:srgbClr val="CBD5E1"/>
+                </a:solidFill>
+                <a:latin typeface="Arial" pitchFamily="34" charset="0"/>
+                <a:ea typeface="Arial" pitchFamily="34" charset="-122"/>
+                <a:cs typeface="Arial" pitchFamily="34" charset="-120"/>
+              </a:rPr>
+              <a:t>Encrypted chunks</a:t>
+            </a:r>
+            <a:endParaRPr lang="en-US" sz="800" dirty="0"/>
+          </a:p>
+        </p:txBody>
+      </p:sp>
+      <p:sp>
+        <p:nvSpPr>
+          <p:cNvPr id="25" name="Shape 23"/>
+          <p:cNvSpPr/>
+          <p:nvPr/>
+        </p:nvSpPr>
+        <p:spPr>
+          <a:xfrm>
+            <a:off x="6858000" y="1508760"/>
+            <a:ext cx="1737360" cy="640080"/>
+          </a:xfrm>
+          <a:prstGeom prst="rect">
+            <a:avLst/>
+          </a:prstGeom>
+          <a:solidFill>
+            <a:srgbClr val="0052FF"/>
+          </a:solidFill>
+          <a:ln w="12700">
+            <a:solidFill>
+              <a:srgbClr val="0052FF"/>
+            </a:solidFill>
+            <a:prstDash val="solid"/>
+          </a:ln>
+        </p:spPr>
+      </p:sp>
+      <p:sp>
+        <p:nvSpPr>
+          <p:cNvPr id="26" name="Text 24"/>
+          <p:cNvSpPr/>
+          <p:nvPr/>
+        </p:nvSpPr>
+        <p:spPr>
+          <a:xfrm>
+            <a:off x="6858000" y="1572768"/>
+            <a:ext cx="1737360" cy="228600"/>
+          </a:xfrm>
+          <a:prstGeom prst="rect">
+            <a:avLst/>
+          </a:prstGeom>
+          <a:noFill/>
+          <a:ln/>
+        </p:spPr>
+        <p:txBody>
+          <a:bodyPr wrap="square" lIns="0" tIns="0" rIns="0" bIns="0" rtlCol="0" anchor="ctr"/>
+          <a:lstStyle/>
+          <a:p>
+            <a:pPr algn="ctr" indent="0" marL="0">
+              <a:buNone/>
+            </a:pPr>
+            <a:r>
+              <a:rPr lang="en-US" sz="1000" b="1" dirty="0">
+                <a:solidFill>
+                  <a:srgbClr val="FFFFFF"/>
+                </a:solidFill>
+                <a:latin typeface="Arial" pitchFamily="34" charset="0"/>
+                <a:ea typeface="Arial" pitchFamily="34" charset="-122"/>
+                <a:cs typeface="Arial" pitchFamily="34" charset="-120"/>
+              </a:rPr>
+              <a:t>Base Sepolia</a:t>
+            </a:r>
+            <a:endParaRPr lang="en-US" sz="1000" dirty="0"/>
+          </a:p>
+        </p:txBody>
+      </p:sp>
+      <p:sp>
+        <p:nvSpPr>
+          <p:cNvPr id="27" name="Text 25"/>
+          <p:cNvSpPr/>
+          <p:nvPr/>
+        </p:nvSpPr>
+        <p:spPr>
+          <a:xfrm>
+            <a:off x="6858000" y="1801368"/>
+            <a:ext cx="1737360" cy="228600"/>
+          </a:xfrm>
+          <a:prstGeom prst="rect">
+            <a:avLst/>
+          </a:prstGeom>
+          <a:noFill/>
+          <a:ln/>
+        </p:spPr>
+        <p:txBody>
+          <a:bodyPr wrap="square" lIns="0" tIns="0" rIns="0" bIns="0" rtlCol="0" anchor="ctr"/>
+          <a:lstStyle/>
+          <a:p>
+            <a:pPr algn="ctr" indent="0" marL="0">
+              <a:buNone/>
+            </a:pPr>
+            <a:r>
+              <a:rPr lang="en-US" sz="800" dirty="0">
+                <a:solidFill>
+                  <a:srgbClr val="CBD5E1"/>
+                </a:solidFill>
+                <a:latin typeface="Arial" pitchFamily="34" charset="0"/>
+                <a:ea typeface="Arial" pitchFamily="34" charset="-122"/>
+                <a:cs typeface="Arial" pitchFamily="34" charset="-120"/>
+              </a:rPr>
+              <a:t>Merkle + Timestamp</a:t>
+            </a:r>
+            <a:endParaRPr lang="en-US" sz="800" dirty="0"/>
+          </a:p>
+        </p:txBody>
+      </p:sp>
+      <p:sp>
+        <p:nvSpPr>
+          <p:cNvPr id="28" name="Shape 26"/>
+          <p:cNvSpPr/>
+          <p:nvPr/>
+        </p:nvSpPr>
+        <p:spPr>
+          <a:xfrm>
+            <a:off x="4937760" y="2331720"/>
+            <a:ext cx="3657600" cy="640080"/>
+          </a:xfrm>
+          <a:prstGeom prst="rect">
+            <a:avLst/>
+          </a:prstGeom>
+          <a:solidFill>
+            <a:srgbClr val="059669"/>
+          </a:solidFill>
+          <a:ln w="12700">
+            <a:solidFill>
+              <a:srgbClr val="059669"/>
+            </a:solidFill>
+            <a:prstDash val="solid"/>
+          </a:ln>
+        </p:spPr>
+      </p:sp>
+      <p:sp>
+        <p:nvSpPr>
+          <p:cNvPr id="29" name="Text 27"/>
+          <p:cNvSpPr/>
+          <p:nvPr/>
+        </p:nvSpPr>
+        <p:spPr>
+          <a:xfrm>
+            <a:off x="4937760" y="2395728"/>
+            <a:ext cx="3657600" cy="228600"/>
+          </a:xfrm>
+          <a:prstGeom prst="rect">
+            <a:avLst/>
+          </a:prstGeom>
+          <a:noFill/>
+          <a:ln/>
+        </p:spPr>
+        <p:txBody>
+          <a:bodyPr wrap="square" lIns="0" tIns="0" rIns="0" bIns="0" rtlCol="0" anchor="ctr"/>
+          <a:lstStyle/>
+          <a:p>
+            <a:pPr algn="ctr" indent="0" marL="0">
+              <a:buNone/>
+            </a:pPr>
+            <a:r>
+              <a:rPr lang="en-US" sz="1000" b="1" dirty="0">
+                <a:solidFill>
+                  <a:srgbClr val="FFFFFF"/>
+                </a:solidFill>
+                <a:latin typeface="Arial" pitchFamily="34" charset="0"/>
+                <a:ea typeface="Arial" pitchFamily="34" charset="-122"/>
+                <a:cs typeface="Arial" pitchFamily="34" charset="-120"/>
+              </a:rPr>
+              <a:t>Semaphore ZK Groups</a:t>
+            </a:r>
+            <a:endParaRPr lang="en-US" sz="1000" dirty="0"/>
+          </a:p>
+        </p:txBody>
+      </p:sp>
+      <p:sp>
+        <p:nvSpPr>
+          <p:cNvPr id="30" name="Text 28"/>
+          <p:cNvSpPr/>
+          <p:nvPr/>
+        </p:nvSpPr>
+        <p:spPr>
+          <a:xfrm>
+            <a:off x="4937760" y="2624328"/>
+            <a:ext cx="3657600" cy="228600"/>
+          </a:xfrm>
+          <a:prstGeom prst="rect">
+            <a:avLst/>
+          </a:prstGeom>
+          <a:noFill/>
+          <a:ln/>
+        </p:spPr>
+        <p:txBody>
+          <a:bodyPr wrap="square" lIns="0" tIns="0" rIns="0" bIns="0" rtlCol="0" anchor="ctr"/>
+          <a:lstStyle/>
+          <a:p>
+            <a:pPr algn="ctr" indent="0" marL="0">
+              <a:buNone/>
+            </a:pPr>
+            <a:r>
+              <a:rPr lang="en-US" sz="800" dirty="0">
+                <a:solidFill>
+                  <a:srgbClr val="CBD5E1"/>
+                </a:solidFill>
+                <a:latin typeface="Arial" pitchFamily="34" charset="0"/>
+                <a:ea typeface="Arial" pitchFamily="34" charset="-122"/>
+                <a:cs typeface="Arial" pitchFamily="34" charset="-120"/>
+              </a:rPr>
+              <a:t>Anonymous attestations • Identity commitments</a:t>
+            </a:r>
+            <a:endParaRPr lang="en-US" sz="800" dirty="0"/>
+          </a:p>
+        </p:txBody>
+      </p:sp>
+      <p:sp>
+        <p:nvSpPr>
+          <p:cNvPr id="31" name="Text 29"/>
+          <p:cNvSpPr/>
+          <p:nvPr/>
+        </p:nvSpPr>
+        <p:spPr>
+          <a:xfrm>
+            <a:off x="4160520" y="1600200"/>
+            <a:ext cx="640080" cy="365760"/>
+          </a:xfrm>
+          <a:prstGeom prst="rect">
+            <a:avLst/>
+          </a:prstGeom>
+          <a:noFill/>
+          <a:ln/>
+        </p:spPr>
+        <p:txBody>
+          <a:bodyPr wrap="square" lIns="0" tIns="0" rIns="0" bIns="0" rtlCol="0" anchor="ctr"/>
+          <a:lstStyle/>
+          <a:p>
+            <a:pPr algn="ctr" indent="0" marL="0">
+              <a:buNone/>
+            </a:pPr>
+            <a:r>
+              <a:rPr lang="en-US" sz="2400" dirty="0">
+                <a:solidFill>
+                  <a:srgbClr val="06B6D4"/>
+                </a:solidFill>
+                <a:latin typeface="Arial" pitchFamily="34" charset="0"/>
+                <a:ea typeface="Arial" pitchFamily="34" charset="-122"/>
+                <a:cs typeface="Arial" pitchFamily="34" charset="-120"/>
+              </a:rPr>
+              <a:t>→</a:t>
+            </a:r>
+            <a:endParaRPr lang="en-US" sz="2400" dirty="0"/>
+          </a:p>
+        </p:txBody>
+      </p:sp>
+      <p:sp>
+        <p:nvSpPr>
+          <p:cNvPr id="32" name="Shape 30"/>
+          <p:cNvSpPr/>
+          <p:nvPr/>
+        </p:nvSpPr>
+        <p:spPr>
+          <a:xfrm>
+            <a:off x="2286000" y="3657600"/>
+            <a:ext cx="4572000" cy="1188720"/>
+          </a:xfrm>
+          <a:prstGeom prst="rect">
+            <a:avLst/>
+          </a:prstGeom>
+          <a:solidFill>
+            <a:srgbClr val="1E293B"/>
+          </a:solidFill>
+          <a:ln w="25400">
+            <a:solidFill>
+              <a:srgbClr val="06B6D4"/>
+            </a:solidFill>
+            <a:prstDash val="solid"/>
+          </a:ln>
+        </p:spPr>
+      </p:sp>
+      <p:sp>
+        <p:nvSpPr>
+          <p:cNvPr id="33" name="Text 31"/>
+          <p:cNvSpPr/>
+          <p:nvPr/>
+        </p:nvSpPr>
+        <p:spPr>
+          <a:xfrm>
+            <a:off x="2377440" y="3703320"/>
+            <a:ext cx="4389120" cy="274320"/>
+          </a:xfrm>
+          <a:prstGeom prst="rect">
+            <a:avLst/>
+          </a:prstGeom>
+          <a:noFill/>
+          <a:ln/>
+        </p:spPr>
+        <p:txBody>
+          <a:bodyPr wrap="square" lIns="0" tIns="0" rIns="0" bIns="0" rtlCol="0" anchor="ctr"/>
+          <a:lstStyle/>
+          <a:p>
+            <a:pPr algn="l" indent="0" marL="0">
+              <a:buNone/>
+            </a:pPr>
+            <a:r>
+              <a:rPr lang="en-US" sz="1200" b="1" dirty="0">
+                <a:solidFill>
+                  <a:srgbClr val="06B6D4"/>
+                </a:solidFill>
+                <a:latin typeface="Arial" pitchFamily="34" charset="0"/>
+                <a:ea typeface="Arial" pitchFamily="34" charset="-122"/>
+                <a:cs typeface="Arial" pitchFamily="34" charset="-120"/>
+              </a:rPr>
+              <a:t>👤 Trusted Contact</a:t>
+            </a:r>
+            <a:endParaRPr lang="en-US" sz="1200" dirty="0"/>
+          </a:p>
+        </p:txBody>
+      </p:sp>
+      <p:sp>
+        <p:nvSpPr>
+          <p:cNvPr id="34" name="Shape 32"/>
+          <p:cNvSpPr/>
+          <p:nvPr/>
+        </p:nvSpPr>
+        <p:spPr>
+          <a:xfrm>
+            <a:off x="2423160" y="4069080"/>
+            <a:ext cx="777240" cy="502920"/>
+          </a:xfrm>
+          <a:prstGeom prst="rect">
+            <a:avLst/>
+          </a:prstGeom>
+          <a:solidFill>
+            <a:srgbClr val="0F172A"/>
+          </a:solidFill>
+          <a:ln w="12700">
+            <a:solidFill>
+              <a:srgbClr val="0891B2"/>
+            </a:solidFill>
+            <a:prstDash val="solid"/>
+          </a:ln>
+        </p:spPr>
+      </p:sp>
+      <p:sp>
+        <p:nvSpPr>
+          <p:cNvPr id="35" name="Text 33"/>
+          <p:cNvSpPr/>
+          <p:nvPr/>
+        </p:nvSpPr>
+        <p:spPr>
+          <a:xfrm>
+            <a:off x="2423160" y="4133088"/>
+            <a:ext cx="777240" cy="365760"/>
+          </a:xfrm>
+          <a:prstGeom prst="rect">
+            <a:avLst/>
+          </a:prstGeom>
+          <a:noFill/>
+          <a:ln/>
+        </p:spPr>
+        <p:txBody>
+          <a:bodyPr wrap="square" lIns="0" tIns="0" rIns="0" bIns="0" rtlCol="0" anchor="ctr"/>
+          <a:lstStyle/>
+          <a:p>
+            <a:pPr algn="ctr" indent="0" marL="0">
+              <a:buNone/>
+            </a:pPr>
+            <a:r>
+              <a:rPr lang="en-US" sz="800" b="1" dirty="0">
+                <a:solidFill>
+                  <a:srgbClr val="FFFFFF"/>
+                </a:solidFill>
+                <a:latin typeface="Arial" pitchFamily="34" charset="0"/>
+                <a:ea typeface="Arial" pitchFamily="34" charset="-122"/>
+                <a:cs typeface="Arial" pitchFamily="34" charset="-120"/>
+              </a:rPr>
+              <a:t>QR Sync</a:t>
+            </a:r>
+            <a:endParaRPr lang="en-US" sz="800" dirty="0"/>
+          </a:p>
+        </p:txBody>
+      </p:sp>
+      <p:sp>
+        <p:nvSpPr>
+          <p:cNvPr id="36" name="Text 34"/>
+          <p:cNvSpPr/>
+          <p:nvPr/>
+        </p:nvSpPr>
+        <p:spPr>
+          <a:xfrm>
+            <a:off x="3154680" y="4160520"/>
+            <a:ext cx="182880" cy="274320"/>
+          </a:xfrm>
+          <a:prstGeom prst="rect">
+            <a:avLst/>
+          </a:prstGeom>
+          <a:noFill/>
+          <a:ln/>
+        </p:spPr>
+        <p:txBody>
+          <a:bodyPr wrap="square" lIns="0" tIns="0" rIns="0" bIns="0" rtlCol="0" anchor="ctr"/>
+          <a:lstStyle/>
+          <a:p>
+            <a:pPr algn="ctr" indent="0" marL="0">
+              <a:buNone/>
+            </a:pPr>
+            <a:r>
+              <a:rPr lang="en-US" sz="1000" dirty="0">
+                <a:solidFill>
+                  <a:srgbClr val="06B6D4"/>
+                </a:solidFill>
+                <a:latin typeface="Arial" pitchFamily="34" charset="0"/>
+                <a:ea typeface="Arial" pitchFamily="34" charset="-122"/>
+                <a:cs typeface="Arial" pitchFamily="34" charset="-120"/>
+              </a:rPr>
+              <a:t>→</a:t>
+            </a:r>
+            <a:endParaRPr lang="en-US" sz="1000" dirty="0"/>
+          </a:p>
+        </p:txBody>
+      </p:sp>
+      <p:sp>
+        <p:nvSpPr>
+          <p:cNvPr id="37" name="Shape 35"/>
+          <p:cNvSpPr/>
+          <p:nvPr/>
+        </p:nvSpPr>
+        <p:spPr>
+          <a:xfrm>
+            <a:off x="3291840" y="4069080"/>
+            <a:ext cx="777240" cy="502920"/>
+          </a:xfrm>
+          <a:prstGeom prst="rect">
+            <a:avLst/>
+          </a:prstGeom>
+          <a:solidFill>
+            <a:srgbClr val="0F172A"/>
+          </a:solidFill>
+          <a:ln w="12700">
+            <a:solidFill>
+              <a:srgbClr val="0891B2"/>
+            </a:solidFill>
+            <a:prstDash val="solid"/>
+          </a:ln>
+        </p:spPr>
+      </p:sp>
+      <p:sp>
+        <p:nvSpPr>
+          <p:cNvPr id="38" name="Text 36"/>
+          <p:cNvSpPr/>
+          <p:nvPr/>
+        </p:nvSpPr>
+        <p:spPr>
+          <a:xfrm>
+            <a:off x="3291840" y="4133088"/>
+            <a:ext cx="777240" cy="365760"/>
+          </a:xfrm>
+          <a:prstGeom prst="rect">
+            <a:avLst/>
+          </a:prstGeom>
+          <a:noFill/>
+          <a:ln/>
+        </p:spPr>
+        <p:txBody>
+          <a:bodyPr wrap="square" lIns="0" tIns="0" rIns="0" bIns="0" rtlCol="0" anchor="ctr"/>
+          <a:lstStyle/>
+          <a:p>
+            <a:pPr algn="ctr" indent="0" marL="0">
+              <a:buNone/>
+            </a:pPr>
+            <a:r>
+              <a:rPr lang="en-US" sz="800" b="1" dirty="0">
+                <a:solidFill>
+                  <a:srgbClr val="FFFFFF"/>
+                </a:solidFill>
+                <a:latin typeface="Arial" pitchFamily="34" charset="0"/>
+                <a:ea typeface="Arial" pitchFamily="34" charset="-122"/>
+                <a:cs typeface="Arial" pitchFamily="34" charset="-120"/>
+              </a:rPr>
+              <a:t>Fetch IPFS</a:t>
+            </a:r>
+            <a:endParaRPr lang="en-US" sz="800" dirty="0"/>
+          </a:p>
+        </p:txBody>
+      </p:sp>
+      <p:sp>
+        <p:nvSpPr>
+          <p:cNvPr id="39" name="Text 37"/>
+          <p:cNvSpPr/>
+          <p:nvPr/>
+        </p:nvSpPr>
+        <p:spPr>
+          <a:xfrm>
+            <a:off x="4023360" y="4160520"/>
+            <a:ext cx="182880" cy="274320"/>
+          </a:xfrm>
+          <a:prstGeom prst="rect">
+            <a:avLst/>
+          </a:prstGeom>
+          <a:noFill/>
+          <a:ln/>
+        </p:spPr>
+        <p:txBody>
+          <a:bodyPr wrap="square" lIns="0" tIns="0" rIns="0" bIns="0" rtlCol="0" anchor="ctr"/>
+          <a:lstStyle/>
+          <a:p>
+            <a:pPr algn="ctr" indent="0" marL="0">
+              <a:buNone/>
+            </a:pPr>
+            <a:r>
+              <a:rPr lang="en-US" sz="1000" dirty="0">
+                <a:solidFill>
+                  <a:srgbClr val="06B6D4"/>
+                </a:solidFill>
+                <a:latin typeface="Arial" pitchFamily="34" charset="0"/>
+                <a:ea typeface="Arial" pitchFamily="34" charset="-122"/>
+                <a:cs typeface="Arial" pitchFamily="34" charset="-120"/>
+              </a:rPr>
+              <a:t>→</a:t>
+            </a:r>
+            <a:endParaRPr lang="en-US" sz="1000" dirty="0"/>
+          </a:p>
+        </p:txBody>
+      </p:sp>
+      <p:sp>
+        <p:nvSpPr>
+          <p:cNvPr id="40" name="Shape 38"/>
+          <p:cNvSpPr/>
+          <p:nvPr/>
+        </p:nvSpPr>
+        <p:spPr>
+          <a:xfrm>
+            <a:off x="4160520" y="4069080"/>
+            <a:ext cx="777240" cy="502920"/>
+          </a:xfrm>
+          <a:prstGeom prst="rect">
+            <a:avLst/>
+          </a:prstGeom>
+          <a:solidFill>
+            <a:srgbClr val="0F172A"/>
+          </a:solidFill>
+          <a:ln w="12700">
+            <a:solidFill>
+              <a:srgbClr val="0891B2"/>
+            </a:solidFill>
+            <a:prstDash val="solid"/>
+          </a:ln>
+        </p:spPr>
+      </p:sp>
+      <p:sp>
+        <p:nvSpPr>
+          <p:cNvPr id="41" name="Text 39"/>
+          <p:cNvSpPr/>
+          <p:nvPr/>
+        </p:nvSpPr>
+        <p:spPr>
+          <a:xfrm>
+            <a:off x="4160520" y="4133088"/>
+            <a:ext cx="777240" cy="365760"/>
+          </a:xfrm>
+          <a:prstGeom prst="rect">
+            <a:avLst/>
+          </a:prstGeom>
+          <a:noFill/>
+          <a:ln/>
+        </p:spPr>
+        <p:txBody>
+          <a:bodyPr wrap="square" lIns="0" tIns="0" rIns="0" bIns="0" rtlCol="0" anchor="ctr"/>
+          <a:lstStyle/>
+          <a:p>
+            <a:pPr algn="ctr" indent="0" marL="0">
+              <a:buNone/>
+            </a:pPr>
+            <a:r>
+              <a:rPr lang="en-US" sz="800" b="1" dirty="0">
+                <a:solidFill>
+                  <a:srgbClr val="FFFFFF"/>
+                </a:solidFill>
+                <a:latin typeface="Arial" pitchFamily="34" charset="0"/>
+                <a:ea typeface="Arial" pitchFamily="34" charset="-122"/>
+                <a:cs typeface="Arial" pitchFamily="34" charset="-120"/>
+              </a:rPr>
+              <a:t>Decrypt</a:t>
+            </a:r>
+            <a:endParaRPr lang="en-US" sz="800" dirty="0"/>
+          </a:p>
+        </p:txBody>
+      </p:sp>
+      <p:sp>
+        <p:nvSpPr>
+          <p:cNvPr id="42" name="Text 40"/>
+          <p:cNvSpPr/>
+          <p:nvPr/>
+        </p:nvSpPr>
+        <p:spPr>
+          <a:xfrm>
+            <a:off x="4892040" y="4160520"/>
+            <a:ext cx="182880" cy="274320"/>
+          </a:xfrm>
+          <a:prstGeom prst="rect">
+            <a:avLst/>
+          </a:prstGeom>
+          <a:noFill/>
+          <a:ln/>
+        </p:spPr>
+        <p:txBody>
+          <a:bodyPr wrap="square" lIns="0" tIns="0" rIns="0" bIns="0" rtlCol="0" anchor="ctr"/>
+          <a:lstStyle/>
+          <a:p>
+            <a:pPr algn="ctr" indent="0" marL="0">
+              <a:buNone/>
+            </a:pPr>
+            <a:r>
+              <a:rPr lang="en-US" sz="1000" dirty="0">
+                <a:solidFill>
+                  <a:srgbClr val="06B6D4"/>
+                </a:solidFill>
+                <a:latin typeface="Arial" pitchFamily="34" charset="0"/>
+                <a:ea typeface="Arial" pitchFamily="34" charset="-122"/>
+                <a:cs typeface="Arial" pitchFamily="34" charset="-120"/>
+              </a:rPr>
+              <a:t>→</a:t>
+            </a:r>
+            <a:endParaRPr lang="en-US" sz="1000" dirty="0"/>
+          </a:p>
+        </p:txBody>
+      </p:sp>
+      <p:sp>
+        <p:nvSpPr>
+          <p:cNvPr id="43" name="Shape 41"/>
+          <p:cNvSpPr/>
+          <p:nvPr/>
+        </p:nvSpPr>
+        <p:spPr>
+          <a:xfrm>
+            <a:off x="5029200" y="4069080"/>
+            <a:ext cx="777240" cy="502920"/>
+          </a:xfrm>
+          <a:prstGeom prst="rect">
+            <a:avLst/>
+          </a:prstGeom>
+          <a:solidFill>
+            <a:srgbClr val="0F172A"/>
+          </a:solidFill>
+          <a:ln w="12700">
+            <a:solidFill>
+              <a:srgbClr val="0891B2"/>
+            </a:solidFill>
+            <a:prstDash val="solid"/>
+          </a:ln>
+        </p:spPr>
+      </p:sp>
+      <p:sp>
+        <p:nvSpPr>
+          <p:cNvPr id="44" name="Text 42"/>
+          <p:cNvSpPr/>
+          <p:nvPr/>
+        </p:nvSpPr>
+        <p:spPr>
+          <a:xfrm>
+            <a:off x="5029200" y="4133088"/>
+            <a:ext cx="777240" cy="365760"/>
+          </a:xfrm>
+          <a:prstGeom prst="rect">
+            <a:avLst/>
+          </a:prstGeom>
+          <a:noFill/>
+          <a:ln/>
+        </p:spPr>
+        <p:txBody>
+          <a:bodyPr wrap="square" lIns="0" tIns="0" rIns="0" bIns="0" rtlCol="0" anchor="ctr"/>
+          <a:lstStyle/>
+          <a:p>
+            <a:pPr algn="ctr" indent="0" marL="0">
+              <a:buNone/>
+            </a:pPr>
+            <a:r>
+              <a:rPr lang="en-US" sz="800" b="1" dirty="0">
+                <a:solidFill>
+                  <a:srgbClr val="FFFFFF"/>
+                </a:solidFill>
+                <a:latin typeface="Arial" pitchFamily="34" charset="0"/>
+                <a:ea typeface="Arial" pitchFamily="34" charset="-122"/>
+                <a:cs typeface="Arial" pitchFamily="34" charset="-120"/>
+              </a:rPr>
+              <a:t>View</a:t>
+            </a:r>
+            <a:endParaRPr lang="en-US" sz="800" dirty="0"/>
+          </a:p>
+        </p:txBody>
+      </p:sp>
+      <p:sp>
+        <p:nvSpPr>
+          <p:cNvPr id="45" name="Text 43"/>
+          <p:cNvSpPr/>
+          <p:nvPr/>
+        </p:nvSpPr>
+        <p:spPr>
+          <a:xfrm>
+            <a:off x="5760720" y="4160520"/>
+            <a:ext cx="182880" cy="274320"/>
+          </a:xfrm>
+          <a:prstGeom prst="rect">
+            <a:avLst/>
+          </a:prstGeom>
+          <a:noFill/>
+          <a:ln/>
+        </p:spPr>
+        <p:txBody>
+          <a:bodyPr wrap="square" lIns="0" tIns="0" rIns="0" bIns="0" rtlCol="0" anchor="ctr"/>
+          <a:lstStyle/>
+          <a:p>
+            <a:pPr algn="ctr" indent="0" marL="0">
+              <a:buNone/>
+            </a:pPr>
+            <a:r>
+              <a:rPr lang="en-US" sz="1000" dirty="0">
+                <a:solidFill>
+                  <a:srgbClr val="06B6D4"/>
+                </a:solidFill>
+                <a:latin typeface="Arial" pitchFamily="34" charset="0"/>
+                <a:ea typeface="Arial" pitchFamily="34" charset="-122"/>
+                <a:cs typeface="Arial" pitchFamily="34" charset="-120"/>
+              </a:rPr>
+              <a:t>→</a:t>
+            </a:r>
+            <a:endParaRPr lang="en-US" sz="1000" dirty="0"/>
+          </a:p>
+        </p:txBody>
+      </p:sp>
+      <p:sp>
+        <p:nvSpPr>
+          <p:cNvPr id="46" name="Shape 44"/>
+          <p:cNvSpPr/>
+          <p:nvPr/>
+        </p:nvSpPr>
+        <p:spPr>
+          <a:xfrm>
+            <a:off x="5897880" y="4069080"/>
+            <a:ext cx="777240" cy="502920"/>
+          </a:xfrm>
+          <a:prstGeom prst="rect">
+            <a:avLst/>
+          </a:prstGeom>
+          <a:solidFill>
+            <a:srgbClr val="0F172A"/>
+          </a:solidFill>
+          <a:ln w="12700">
+            <a:solidFill>
+              <a:srgbClr val="0891B2"/>
+            </a:solidFill>
+            <a:prstDash val="solid"/>
+          </a:ln>
+        </p:spPr>
+      </p:sp>
+      <p:sp>
+        <p:nvSpPr>
+          <p:cNvPr id="47" name="Text 45"/>
+          <p:cNvSpPr/>
+          <p:nvPr/>
+        </p:nvSpPr>
+        <p:spPr>
+          <a:xfrm>
+            <a:off x="5897880" y="4133088"/>
+            <a:ext cx="777240" cy="365760"/>
+          </a:xfrm>
+          <a:prstGeom prst="rect">
+            <a:avLst/>
+          </a:prstGeom>
+          <a:noFill/>
+          <a:ln/>
+        </p:spPr>
+        <p:txBody>
+          <a:bodyPr wrap="square" lIns="0" tIns="0" rIns="0" bIns="0" rtlCol="0" anchor="ctr"/>
+          <a:lstStyle/>
+          <a:p>
+            <a:pPr algn="ctr" indent="0" marL="0">
+              <a:buNone/>
+            </a:pPr>
+            <a:r>
+              <a:rPr lang="en-US" sz="800" b="1" dirty="0">
+                <a:solidFill>
+                  <a:srgbClr val="FFFFFF"/>
+                </a:solidFill>
+                <a:latin typeface="Arial" pitchFamily="34" charset="0"/>
+                <a:ea typeface="Arial" pitchFamily="34" charset="-122"/>
+                <a:cs typeface="Arial" pitchFamily="34" charset="-120"/>
+              </a:rPr>
+              <a:t>Attest (ZK)</a:t>
+            </a:r>
+            <a:endParaRPr lang="en-US" sz="800" dirty="0"/>
+          </a:p>
+        </p:txBody>
+      </p:sp>
+      <p:sp>
+        <p:nvSpPr>
+          <p:cNvPr id="48" name="Text 46"/>
+          <p:cNvSpPr/>
+          <p:nvPr/>
+        </p:nvSpPr>
+        <p:spPr>
+          <a:xfrm>
+            <a:off x="6583680" y="3108960"/>
+            <a:ext cx="457200" cy="457200"/>
+          </a:xfrm>
+          <a:prstGeom prst="rect">
+            <a:avLst/>
+          </a:prstGeom>
+          <a:noFill/>
+          <a:ln/>
+        </p:spPr>
+        <p:txBody>
+          <a:bodyPr wrap="square" lIns="0" tIns="0" rIns="0" bIns="0" rtlCol="0" anchor="ctr"/>
+          <a:lstStyle/>
+          <a:p>
+            <a:pPr algn="ctr" indent="0" marL="0">
+              <a:buNone/>
+            </a:pPr>
+            <a:r>
+              <a:rPr lang="en-US" sz="2000" dirty="0">
+                <a:solidFill>
+                  <a:srgbClr val="06B6D4"/>
+                </a:solidFill>
+                <a:latin typeface="Arial" pitchFamily="34" charset="0"/>
+                <a:ea typeface="Arial" pitchFamily="34" charset="-122"/>
+                <a:cs typeface="Arial" pitchFamily="34" charset="-120"/>
+              </a:rPr>
+              <a:t>↓</a:t>
+            </a:r>
+            <a:endParaRPr lang="en-US" sz="2000" dirty="0"/>
+          </a:p>
+        </p:txBody>
+      </p:sp>
+    </p:spTree>
+  </p:cSld>
+  <p:clrMapOvr>
+    <a:masterClrMapping/>
+  </p:clrMapOvr>
+</p:sld>
+</file>
+
+<file path=ppt/slides/slide7.xml><?xml version="1.0" encoding="utf-8"?>
+<p:sld xmlns:a="http://schemas.openxmlformats.org/drawingml/2006/main" xmlns:r="http://schemas.openxmlformats.org/officeDocument/2006/relationships" xmlns:p="http://schemas.openxmlformats.org/presentationml/2006/main">
+  <p:cSld name="Slide 7">
+    <p:bg>
+      <p:bgPr>
+        <a:solidFill>
+          <a:srgbClr val="0F172A"/>
+        </a:solidFill>
+      </p:bgPr>
+    </p:bg>
+    <p:spTree>
+      <p:nvGrpSpPr>
+        <p:cNvPr id="1" name=""/>
+        <p:cNvGrpSpPr/>
+        <p:nvPr/>
+      </p:nvGrpSpPr>
+      <p:grpSpPr>
+        <a:xfrm>
+          <a:off x="0" y="0"/>
+          <a:ext cx="0" cy="0"/>
+          <a:chOff x="0" y="0"/>
+          <a:chExt cx="0" cy="0"/>
+        </a:xfrm>
+      </p:grpSpPr>
+      <p:sp>
+        <p:nvSpPr>
+          <p:cNvPr id="2" name="Text 0"/>
+          <p:cNvSpPr/>
+          <p:nvPr/>
+        </p:nvSpPr>
+        <p:spPr>
+          <a:xfrm>
+            <a:off x="457200" y="228600"/>
+            <a:ext cx="8229600" cy="457200"/>
+          </a:xfrm>
+          <a:prstGeom prst="rect">
+            <a:avLst/>
+          </a:prstGeom>
+          <a:noFill/>
+          <a:ln/>
+        </p:spPr>
+        <p:txBody>
+          <a:bodyPr wrap="square" lIns="0" tIns="0" rIns="0" bIns="0" rtlCol="0" anchor="ctr"/>
+          <a:lstStyle/>
+          <a:p>
+            <a:pPr algn="ctr" indent="0" marL="0">
+              <a:buNone/>
+            </a:pPr>
+            <a:r>
+              <a:rPr lang="en-US" sz="2800" b="1" dirty="0">
+                <a:solidFill>
+                  <a:srgbClr val="FFFFFF"/>
+                </a:solidFill>
+                <a:latin typeface="Arial Black" pitchFamily="34" charset="0"/>
+                <a:ea typeface="Arial Black" pitchFamily="34" charset="-122"/>
+                <a:cs typeface="Arial Black" pitchFamily="34" charset="-120"/>
+              </a:rPr>
+              <a:t>Ideal Architecture</a:t>
+            </a:r>
+            <a:endParaRPr lang="en-US" sz="2800" dirty="0"/>
+          </a:p>
+        </p:txBody>
+      </p:sp>
+      <p:sp>
+        <p:nvSpPr>
+          <p:cNvPr id="3" name="Text 1"/>
+          <p:cNvSpPr/>
+          <p:nvPr/>
+        </p:nvSpPr>
+        <p:spPr>
+          <a:xfrm>
+            <a:off x="457200" y="621792"/>
+            <a:ext cx="8229600" cy="274320"/>
+          </a:xfrm>
+          <a:prstGeom prst="rect">
+            <a:avLst/>
+          </a:prstGeom>
+          <a:noFill/>
+          <a:ln/>
+        </p:spPr>
+        <p:txBody>
+          <a:bodyPr wrap="square" lIns="0" tIns="0" rIns="0" bIns="0" rtlCol="0" anchor="ctr"/>
+          <a:lstStyle/>
+          <a:p>
+            <a:pPr algn="ctr" indent="0" marL="0">
+              <a:buNone/>
+            </a:pPr>
+            <a:r>
+              <a:rPr lang="en-US" sz="1300" dirty="0">
+                <a:solidFill>
+                  <a:srgbClr val="94A3B8"/>
+                </a:solidFill>
+                <a:latin typeface="Arial" pitchFamily="34" charset="0"/>
+                <a:ea typeface="Arial" pitchFamily="34" charset="-122"/>
+                <a:cs typeface="Arial" pitchFamily="34" charset="-120"/>
+              </a:rPr>
+              <a:t>Matrix Server + zkTLS • Dual-Path Redundancy</a:t>
+            </a:r>
+            <a:endParaRPr lang="en-US" sz="1300" dirty="0"/>
+          </a:p>
+        </p:txBody>
+      </p:sp>
+      <p:sp>
+        <p:nvSpPr>
+          <p:cNvPr id="4" name="Shape 2"/>
+          <p:cNvSpPr/>
+          <p:nvPr/>
+        </p:nvSpPr>
+        <p:spPr>
+          <a:xfrm>
+            <a:off x="274320" y="960120"/>
+            <a:ext cx="2560320" cy="1645920"/>
+          </a:xfrm>
+          <a:prstGeom prst="rect">
+            <a:avLst/>
+          </a:prstGeom>
+          <a:solidFill>
+            <a:srgbClr val="1E293B"/>
+          </a:solidFill>
+          <a:ln w="25400">
+            <a:solidFill>
+              <a:srgbClr val="06B6D4"/>
+            </a:solidFill>
+            <a:prstDash val="solid"/>
+          </a:ln>
+        </p:spPr>
+      </p:sp>
+      <p:sp>
+        <p:nvSpPr>
+          <p:cNvPr id="5" name="Text 3"/>
+          <p:cNvSpPr/>
+          <p:nvPr/>
+        </p:nvSpPr>
+        <p:spPr>
+          <a:xfrm>
+            <a:off x="365760" y="1005840"/>
+            <a:ext cx="2377440" cy="274320"/>
+          </a:xfrm>
+          <a:prstGeom prst="rect">
+            <a:avLst/>
+          </a:prstGeom>
+          <a:noFill/>
+          <a:ln/>
+        </p:spPr>
+        <p:txBody>
+          <a:bodyPr wrap="square" lIns="0" tIns="0" rIns="0" bIns="0" rtlCol="0" anchor="ctr"/>
+          <a:lstStyle/>
+          <a:p>
+            <a:pPr algn="l" indent="0" marL="0">
+              <a:buNone/>
+            </a:pPr>
+            <a:r>
+              <a:rPr lang="en-US" sz="1100" b="1" dirty="0">
+                <a:solidFill>
+                  <a:srgbClr val="06B6D4"/>
+                </a:solidFill>
+                <a:latin typeface="Arial" pitchFamily="34" charset="0"/>
+                <a:ea typeface="Arial" pitchFamily="34" charset="-122"/>
+                <a:cs typeface="Arial" pitchFamily="34" charset="-120"/>
+              </a:rPr>
+              <a:t>📱 Phone (PWA)</a:t>
+            </a:r>
+            <a:endParaRPr lang="en-US" sz="1100" dirty="0"/>
+          </a:p>
+        </p:txBody>
+      </p:sp>
+      <p:sp>
+        <p:nvSpPr>
+          <p:cNvPr id="6" name="Shape 4"/>
+          <p:cNvSpPr/>
+          <p:nvPr/>
+        </p:nvSpPr>
+        <p:spPr>
+          <a:xfrm>
+            <a:off x="411480" y="1371600"/>
+            <a:ext cx="2286000" cy="320040"/>
+          </a:xfrm>
+          <a:prstGeom prst="rect">
+            <a:avLst/>
+          </a:prstGeom>
+          <a:solidFill>
+            <a:srgbClr val="0F172A"/>
+          </a:solidFill>
+          <a:ln w="12700">
+            <a:solidFill>
+              <a:srgbClr val="0891B2"/>
+            </a:solidFill>
+            <a:prstDash val="solid"/>
+          </a:ln>
+        </p:spPr>
+      </p:sp>
+      <p:sp>
+        <p:nvSpPr>
+          <p:cNvPr id="7" name="Text 5"/>
+          <p:cNvSpPr/>
+          <p:nvPr/>
+        </p:nvSpPr>
+        <p:spPr>
+          <a:xfrm>
+            <a:off x="411480" y="1417320"/>
+            <a:ext cx="2286000" cy="228600"/>
+          </a:xfrm>
+          <a:prstGeom prst="rect">
+            <a:avLst/>
+          </a:prstGeom>
+          <a:noFill/>
+          <a:ln/>
+        </p:spPr>
+        <p:txBody>
+          <a:bodyPr wrap="square" lIns="0" tIns="0" rIns="0" bIns="0" rtlCol="0" anchor="ctr"/>
+          <a:lstStyle/>
+          <a:p>
+            <a:pPr algn="ctr" indent="0" marL="0">
+              <a:buNone/>
+            </a:pPr>
+            <a:r>
+              <a:rPr lang="en-US" sz="900" b="1" dirty="0">
+                <a:solidFill>
+                  <a:srgbClr val="FFFFFF"/>
+                </a:solidFill>
+                <a:latin typeface="Arial" pitchFamily="34" charset="0"/>
+                <a:ea typeface="Arial" pitchFamily="34" charset="-122"/>
+                <a:cs typeface="Arial" pitchFamily="34" charset="-120"/>
+              </a:rPr>
+              <a:t>Capture</a:t>
+            </a:r>
+            <a:endParaRPr lang="en-US" sz="900" dirty="0"/>
+          </a:p>
+        </p:txBody>
+      </p:sp>
+      <p:sp>
+        <p:nvSpPr>
+          <p:cNvPr id="8" name="Shape 6"/>
+          <p:cNvSpPr/>
+          <p:nvPr/>
+        </p:nvSpPr>
+        <p:spPr>
+          <a:xfrm>
+            <a:off x="411480" y="1783080"/>
+            <a:ext cx="2286000" cy="320040"/>
+          </a:xfrm>
+          <a:prstGeom prst="rect">
+            <a:avLst/>
+          </a:prstGeom>
+          <a:solidFill>
+            <a:srgbClr val="0F172A"/>
+          </a:solidFill>
+          <a:ln w="12700">
+            <a:solidFill>
+              <a:srgbClr val="0891B2"/>
+            </a:solidFill>
+            <a:prstDash val="solid"/>
+          </a:ln>
+        </p:spPr>
+      </p:sp>
+      <p:sp>
+        <p:nvSpPr>
+          <p:cNvPr id="9" name="Text 7"/>
+          <p:cNvSpPr/>
+          <p:nvPr/>
+        </p:nvSpPr>
+        <p:spPr>
+          <a:xfrm>
+            <a:off x="411480" y="1828800"/>
+            <a:ext cx="2286000" cy="228600"/>
+          </a:xfrm>
+          <a:prstGeom prst="rect">
+            <a:avLst/>
+          </a:prstGeom>
+          <a:noFill/>
+          <a:ln/>
+        </p:spPr>
+        <p:txBody>
+          <a:bodyPr wrap="square" lIns="0" tIns="0" rIns="0" bIns="0" rtlCol="0" anchor="ctr"/>
+          <a:lstStyle/>
+          <a:p>
+            <a:pPr algn="ctr" indent="0" marL="0">
+              <a:buNone/>
+            </a:pPr>
+            <a:r>
+              <a:rPr lang="en-US" sz="900" b="1" dirty="0">
+                <a:solidFill>
+                  <a:srgbClr val="FFFFFF"/>
+                </a:solidFill>
+                <a:latin typeface="Arial" pitchFamily="34" charset="0"/>
+                <a:ea typeface="Arial" pitchFamily="34" charset="-122"/>
+                <a:cs typeface="Arial" pitchFamily="34" charset="-120"/>
+              </a:rPr>
+              <a:t>Encrypt (AES-256)</a:t>
+            </a:r>
+            <a:endParaRPr lang="en-US" sz="900" dirty="0"/>
+          </a:p>
+        </p:txBody>
+      </p:sp>
+      <p:sp>
+        <p:nvSpPr>
+          <p:cNvPr id="10" name="Shape 8"/>
+          <p:cNvSpPr/>
+          <p:nvPr/>
+        </p:nvSpPr>
+        <p:spPr>
+          <a:xfrm>
+            <a:off x="411480" y="2194560"/>
+            <a:ext cx="2286000" cy="320040"/>
+          </a:xfrm>
+          <a:prstGeom prst="rect">
+            <a:avLst/>
+          </a:prstGeom>
+          <a:solidFill>
+            <a:srgbClr val="0F172A"/>
+          </a:solidFill>
+          <a:ln w="12700">
+            <a:solidFill>
+              <a:srgbClr val="0891B2"/>
+            </a:solidFill>
+            <a:prstDash val="solid"/>
+          </a:ln>
+        </p:spPr>
+      </p:sp>
+      <p:sp>
+        <p:nvSpPr>
+          <p:cNvPr id="11" name="Text 9"/>
+          <p:cNvSpPr/>
+          <p:nvPr/>
+        </p:nvSpPr>
+        <p:spPr>
+          <a:xfrm>
+            <a:off x="411480" y="2240280"/>
+            <a:ext cx="2286000" cy="228600"/>
+          </a:xfrm>
+          <a:prstGeom prst="rect">
+            <a:avLst/>
+          </a:prstGeom>
+          <a:noFill/>
+          <a:ln/>
+        </p:spPr>
+        <p:txBody>
+          <a:bodyPr wrap="square" lIns="0" tIns="0" rIns="0" bIns="0" rtlCol="0" anchor="ctr"/>
+          <a:lstStyle/>
+          <a:p>
+            <a:pPr algn="ctr" indent="0" marL="0">
+              <a:buNone/>
+            </a:pPr>
+            <a:r>
+              <a:rPr lang="en-US" sz="900" b="1" dirty="0">
+                <a:solidFill>
+                  <a:srgbClr val="FFFFFF"/>
+                </a:solidFill>
+                <a:latin typeface="Arial" pitchFamily="34" charset="0"/>
+                <a:ea typeface="Arial" pitchFamily="34" charset="-122"/>
+                <a:cs typeface="Arial" pitchFamily="34" charset="-120"/>
+              </a:rPr>
+              <a:t>Chunk + Hash</a:t>
+            </a:r>
+            <a:endParaRPr lang="en-US" sz="900" dirty="0"/>
+          </a:p>
+        </p:txBody>
+      </p:sp>
+      <p:sp>
+        <p:nvSpPr>
+          <p:cNvPr id="12" name="Text 10"/>
+          <p:cNvSpPr/>
+          <p:nvPr/>
+        </p:nvSpPr>
+        <p:spPr>
+          <a:xfrm>
+            <a:off x="3017520" y="1051560"/>
+            <a:ext cx="914400" cy="228600"/>
+          </a:xfrm>
+          <a:prstGeom prst="rect">
+            <a:avLst/>
+          </a:prstGeom>
+          <a:noFill/>
+          <a:ln/>
+        </p:spPr>
+        <p:txBody>
+          <a:bodyPr wrap="square" lIns="0" tIns="0" rIns="0" bIns="0" rtlCol="0" anchor="ctr"/>
+          <a:lstStyle/>
+          <a:p>
+            <a:pPr algn="ctr" indent="0" marL="0">
+              <a:buNone/>
+            </a:pPr>
+            <a:r>
+              <a:rPr lang="en-US" sz="800" b="1" dirty="0">
+                <a:solidFill>
+                  <a:srgbClr val="94A3B8"/>
+                </a:solidFill>
+                <a:latin typeface="Arial" pitchFamily="34" charset="0"/>
+                <a:ea typeface="Arial" pitchFamily="34" charset="-122"/>
+                <a:cs typeface="Arial" pitchFamily="34" charset="-120"/>
+              </a:rPr>
+              <a:t>DUAL PATH</a:t>
+            </a:r>
+            <a:endParaRPr lang="en-US" sz="800" dirty="0"/>
+          </a:p>
+        </p:txBody>
+      </p:sp>
+      <p:sp>
+        <p:nvSpPr>
+          <p:cNvPr id="13" name="Shape 11"/>
+          <p:cNvSpPr/>
+          <p:nvPr/>
+        </p:nvSpPr>
+        <p:spPr>
+          <a:xfrm>
+            <a:off x="2926080" y="1371600"/>
+            <a:ext cx="1097280" cy="457200"/>
+          </a:xfrm>
+          <a:prstGeom prst="rect">
+            <a:avLst/>
+          </a:prstGeom>
+          <a:solidFill>
+            <a:srgbClr val="0F172A"/>
+          </a:solidFill>
+          <a:ln w="12700">
+            <a:solidFill>
+              <a:srgbClr val="0891B2"/>
+            </a:solidFill>
+            <a:prstDash val="dash"/>
+          </a:ln>
+        </p:spPr>
+      </p:sp>
+      <p:sp>
+        <p:nvSpPr>
+          <p:cNvPr id="14" name="Text 12"/>
+          <p:cNvSpPr/>
+          <p:nvPr/>
+        </p:nvSpPr>
+        <p:spPr>
+          <a:xfrm>
+            <a:off x="2926080" y="1417320"/>
+            <a:ext cx="1097280" cy="365760"/>
+          </a:xfrm>
+          <a:prstGeom prst="rect">
+            <a:avLst/>
+          </a:prstGeom>
+          <a:noFill/>
+          <a:ln/>
+        </p:spPr>
+        <p:txBody>
+          <a:bodyPr wrap="square" lIns="0" tIns="0" rIns="0" bIns="0" rtlCol="0" anchor="ctr"/>
+          <a:lstStyle/>
+          <a:p>
+            <a:pPr algn="ctr" indent="0" marL="0">
+              <a:buNone/>
+            </a:pPr>
+            <a:r>
+              <a:rPr lang="en-US" sz="900" dirty="0">
+                <a:solidFill>
+                  <a:srgbClr val="CBD5E1"/>
+                </a:solidFill>
+                <a:latin typeface="Arial" pitchFamily="34" charset="0"/>
+                <a:ea typeface="Arial" pitchFamily="34" charset="-122"/>
+                <a:cs typeface="Arial" pitchFamily="34" charset="-120"/>
+              </a:rPr>
+              <a:t>Direct →</a:t>
+            </a:r>
+            <a:endParaRPr lang="en-US" sz="900" dirty="0"/>
+          </a:p>
+        </p:txBody>
+      </p:sp>
+      <p:sp>
+        <p:nvSpPr>
+          <p:cNvPr id="15" name="Shape 13"/>
+          <p:cNvSpPr/>
+          <p:nvPr/>
+        </p:nvSpPr>
+        <p:spPr>
+          <a:xfrm>
+            <a:off x="2926080" y="1965960"/>
+            <a:ext cx="1097280" cy="457200"/>
+          </a:xfrm>
+          <a:prstGeom prst="rect">
+            <a:avLst/>
+          </a:prstGeom>
+          <a:solidFill>
+            <a:srgbClr val="7C3AED">
+              <a:alpha val="70000"/>
+            </a:srgbClr>
+          </a:solidFill>
+          <a:ln w="25400">
+            <a:solidFill>
+              <a:srgbClr val="7C3AED"/>
+            </a:solidFill>
+            <a:prstDash val="solid"/>
+          </a:ln>
+        </p:spPr>
+      </p:sp>
+      <p:sp>
+        <p:nvSpPr>
+          <p:cNvPr id="16" name="Text 14"/>
+          <p:cNvSpPr/>
+          <p:nvPr/>
+        </p:nvSpPr>
+        <p:spPr>
+          <a:xfrm>
+            <a:off x="2926080" y="2011680"/>
+            <a:ext cx="1097280" cy="365760"/>
+          </a:xfrm>
+          <a:prstGeom prst="rect">
+            <a:avLst/>
+          </a:prstGeom>
+          <a:noFill/>
+          <a:ln/>
+        </p:spPr>
+        <p:txBody>
+          <a:bodyPr wrap="square" lIns="0" tIns="0" rIns="0" bIns="0" rtlCol="0" anchor="ctr"/>
+          <a:lstStyle/>
+          <a:p>
+            <a:pPr algn="ctr" indent="0" marL="0">
+              <a:buNone/>
+            </a:pPr>
+            <a:r>
+              <a:rPr lang="en-US" sz="900" b="1" dirty="0">
+                <a:solidFill>
+                  <a:srgbClr val="FFFFFF"/>
+                </a:solidFill>
+                <a:latin typeface="Arial" pitchFamily="34" charset="0"/>
+                <a:ea typeface="Arial" pitchFamily="34" charset="-122"/>
+                <a:cs typeface="Arial" pitchFamily="34" charset="-120"/>
+              </a:rPr>
+              <a:t>zkTLS →</a:t>
+            </a:r>
+            <a:endParaRPr lang="en-US" sz="900" dirty="0"/>
+          </a:p>
+        </p:txBody>
+      </p:sp>
+      <p:sp>
+        <p:nvSpPr>
+          <p:cNvPr id="17" name="Shape 15"/>
+          <p:cNvSpPr/>
+          <p:nvPr/>
+        </p:nvSpPr>
+        <p:spPr>
+          <a:xfrm>
+            <a:off x="4206240" y="1234440"/>
+            <a:ext cx="1463040" cy="731520"/>
+          </a:xfrm>
+          <a:prstGeom prst="rect">
+            <a:avLst/>
+          </a:prstGeom>
+          <a:solidFill>
+            <a:srgbClr val="065A82"/>
+          </a:solidFill>
+          <a:ln w="12700">
+            <a:solidFill>
+              <a:srgbClr val="065A82"/>
+            </a:solidFill>
+            <a:prstDash val="solid"/>
+          </a:ln>
+        </p:spPr>
+      </p:sp>
+      <p:sp>
+        <p:nvSpPr>
+          <p:cNvPr id="18" name="Text 16"/>
+          <p:cNvSpPr/>
+          <p:nvPr/>
+        </p:nvSpPr>
+        <p:spPr>
+          <a:xfrm>
+            <a:off x="4206240" y="1298448"/>
+            <a:ext cx="1463040" cy="228600"/>
+          </a:xfrm>
+          <a:prstGeom prst="rect">
+            <a:avLst/>
+          </a:prstGeom>
+          <a:noFill/>
+          <a:ln/>
+        </p:spPr>
+        <p:txBody>
+          <a:bodyPr wrap="square" lIns="0" tIns="0" rIns="0" bIns="0" rtlCol="0" anchor="ctr"/>
+          <a:lstStyle/>
+          <a:p>
+            <a:pPr algn="ctr" indent="0" marL="0">
+              <a:buNone/>
+            </a:pPr>
+            <a:r>
+              <a:rPr lang="en-US" sz="1000" b="1" dirty="0">
+                <a:solidFill>
+                  <a:srgbClr val="FFFFFF"/>
+                </a:solidFill>
+                <a:latin typeface="Arial" pitchFamily="34" charset="0"/>
+                <a:ea typeface="Arial" pitchFamily="34" charset="-122"/>
+                <a:cs typeface="Arial" pitchFamily="34" charset="-120"/>
+              </a:rPr>
+              <a:t>IPFS</a:t>
+            </a:r>
+            <a:endParaRPr lang="en-US" sz="1000" dirty="0"/>
+          </a:p>
+        </p:txBody>
+      </p:sp>
+      <p:sp>
+        <p:nvSpPr>
+          <p:cNvPr id="19" name="Text 17"/>
+          <p:cNvSpPr/>
+          <p:nvPr/>
+        </p:nvSpPr>
+        <p:spPr>
+          <a:xfrm>
+            <a:off x="4206240" y="1527048"/>
+            <a:ext cx="1463040" cy="228600"/>
+          </a:xfrm>
+          <a:prstGeom prst="rect">
+            <a:avLst/>
+          </a:prstGeom>
+          <a:noFill/>
+          <a:ln/>
+        </p:spPr>
+        <p:txBody>
+          <a:bodyPr wrap="square" lIns="0" tIns="0" rIns="0" bIns="0" rtlCol="0" anchor="ctr"/>
+          <a:lstStyle/>
+          <a:p>
+            <a:pPr algn="ctr" indent="0" marL="0">
+              <a:buNone/>
+            </a:pPr>
+            <a:r>
+              <a:rPr lang="en-US" sz="800" dirty="0">
+                <a:solidFill>
+                  <a:srgbClr val="CBD5E1"/>
+                </a:solidFill>
+                <a:latin typeface="Arial" pitchFamily="34" charset="0"/>
+                <a:ea typeface="Arial" pitchFamily="34" charset="-122"/>
+                <a:cs typeface="Arial" pitchFamily="34" charset="-120"/>
+              </a:rPr>
+              <a:t>(Direct Upload)</a:t>
+            </a:r>
+            <a:endParaRPr lang="en-US" sz="800" dirty="0"/>
+          </a:p>
+        </p:txBody>
+      </p:sp>
+      <p:sp>
+        <p:nvSpPr>
+          <p:cNvPr id="20" name="Shape 18"/>
+          <p:cNvSpPr/>
+          <p:nvPr/>
+        </p:nvSpPr>
+        <p:spPr>
+          <a:xfrm>
+            <a:off x="4160520" y="2148840"/>
+            <a:ext cx="3017520" cy="2286000"/>
+          </a:xfrm>
+          <a:prstGeom prst="rect">
+            <a:avLst/>
+          </a:prstGeom>
+          <a:solidFill>
+            <a:srgbClr val="1E293B"/>
+          </a:solidFill>
+          <a:ln w="25400">
+            <a:solidFill>
+              <a:srgbClr val="7C3AED"/>
+            </a:solidFill>
+            <a:prstDash val="solid"/>
+          </a:ln>
+        </p:spPr>
+      </p:sp>
+      <p:sp>
+        <p:nvSpPr>
+          <p:cNvPr id="21" name="Text 19"/>
+          <p:cNvSpPr/>
+          <p:nvPr/>
+        </p:nvSpPr>
+        <p:spPr>
+          <a:xfrm>
+            <a:off x="4251960" y="2194560"/>
+            <a:ext cx="2834640" cy="274320"/>
+          </a:xfrm>
+          <a:prstGeom prst="rect">
+            <a:avLst/>
+          </a:prstGeom>
+          <a:noFill/>
+          <a:ln/>
+        </p:spPr>
+        <p:txBody>
+          <a:bodyPr wrap="square" lIns="0" tIns="0" rIns="0" bIns="0" rtlCol="0" anchor="ctr"/>
+          <a:lstStyle/>
+          <a:p>
+            <a:pPr algn="l" indent="0" marL="0">
+              <a:buNone/>
+            </a:pPr>
+            <a:r>
+              <a:rPr lang="en-US" sz="1100" b="1" dirty="0">
+                <a:solidFill>
+                  <a:srgbClr val="A78BFA"/>
+                </a:solidFill>
+                <a:latin typeface="Arial" pitchFamily="34" charset="0"/>
+                <a:ea typeface="Arial" pitchFamily="34" charset="-122"/>
+                <a:cs typeface="Arial" pitchFamily="34" charset="-120"/>
+              </a:rPr>
+              <a:t>🖥️ Matrix Server</a:t>
+            </a:r>
+            <a:endParaRPr lang="en-US" sz="1100" dirty="0"/>
+          </a:p>
+        </p:txBody>
+      </p:sp>
+      <p:sp>
+        <p:nvSpPr>
+          <p:cNvPr id="22" name="Text 20"/>
+          <p:cNvSpPr/>
+          <p:nvPr/>
+        </p:nvSpPr>
+        <p:spPr>
+          <a:xfrm>
+            <a:off x="4251960" y="2423160"/>
+            <a:ext cx="2834640" cy="228600"/>
+          </a:xfrm>
+          <a:prstGeom prst="rect">
+            <a:avLst/>
+          </a:prstGeom>
+          <a:noFill/>
+          <a:ln/>
+        </p:spPr>
+        <p:txBody>
+          <a:bodyPr wrap="square" lIns="0" tIns="0" rIns="0" bIns="0" rtlCol="0" anchor="ctr"/>
+          <a:lstStyle/>
+          <a:p>
+            <a:pPr algn="l" indent="0" marL="0">
+              <a:buNone/>
+            </a:pPr>
+            <a:r>
+              <a:rPr lang="en-US" sz="900" dirty="0">
+                <a:solidFill>
+                  <a:srgbClr val="94A3B8"/>
+                </a:solidFill>
+                <a:latin typeface="Arial" pitchFamily="34" charset="0"/>
+                <a:ea typeface="Arial" pitchFamily="34" charset="-122"/>
+                <a:cs typeface="Arial" pitchFamily="34" charset="-120"/>
+              </a:rPr>
+              <a:t>Trusted Operator (Synapse)</a:t>
+            </a:r>
+            <a:endParaRPr lang="en-US" sz="900" dirty="0"/>
+          </a:p>
+        </p:txBody>
+      </p:sp>
+      <p:sp>
+        <p:nvSpPr>
+          <p:cNvPr id="23" name="Text 21"/>
+          <p:cNvSpPr/>
+          <p:nvPr/>
+        </p:nvSpPr>
+        <p:spPr>
+          <a:xfrm>
+            <a:off x="4297680" y="2743200"/>
+            <a:ext cx="1371600" cy="274320"/>
+          </a:xfrm>
+          <a:prstGeom prst="rect">
+            <a:avLst/>
+          </a:prstGeom>
+          <a:noFill/>
+          <a:ln/>
+        </p:spPr>
+        <p:txBody>
+          <a:bodyPr wrap="square" lIns="0" tIns="0" rIns="0" bIns="0" rtlCol="0" anchor="ctr"/>
+          <a:lstStyle/>
+          <a:p>
+            <a:pPr algn="l" indent="0" marL="0">
+              <a:buNone/>
+            </a:pPr>
+            <a:r>
+              <a:rPr lang="en-US" sz="900" b="1" dirty="0">
+                <a:solidFill>
+                  <a:srgbClr val="FFFFFF"/>
+                </a:solidFill>
+                <a:latin typeface="Arial" pitchFamily="34" charset="0"/>
+                <a:ea typeface="Arial" pitchFamily="34" charset="-122"/>
+                <a:cs typeface="Arial" pitchFamily="34" charset="-120"/>
+              </a:rPr>
+              <a:t>🔐 zkTLS Verify</a:t>
+            </a:r>
+            <a:endParaRPr lang="en-US" sz="900" dirty="0"/>
+          </a:p>
+        </p:txBody>
+      </p:sp>
+      <p:sp>
+        <p:nvSpPr>
+          <p:cNvPr id="24" name="Text 22"/>
+          <p:cNvSpPr/>
+          <p:nvPr/>
+        </p:nvSpPr>
+        <p:spPr>
+          <a:xfrm>
+            <a:off x="5669280" y="2743200"/>
+            <a:ext cx="1371600" cy="274320"/>
+          </a:xfrm>
+          <a:prstGeom prst="rect">
+            <a:avLst/>
+          </a:prstGeom>
+          <a:noFill/>
+          <a:ln/>
+        </p:spPr>
+        <p:txBody>
+          <a:bodyPr wrap="square" lIns="0" tIns="0" rIns="0" bIns="0" rtlCol="0" anchor="ctr"/>
+          <a:lstStyle/>
+          <a:p>
+            <a:pPr algn="l" indent="0" marL="0">
+              <a:buNone/>
+            </a:pPr>
+            <a:r>
+              <a:rPr lang="en-US" sz="800" dirty="0">
+                <a:solidFill>
+                  <a:srgbClr val="CBD5E1"/>
+                </a:solidFill>
+                <a:latin typeface="Arial" pitchFamily="34" charset="0"/>
+                <a:ea typeface="Arial" pitchFamily="34" charset="-122"/>
+                <a:cs typeface="Arial" pitchFamily="34" charset="-120"/>
+              </a:rPr>
+              <a:t>Prove data origin</a:t>
+            </a:r>
+            <a:endParaRPr lang="en-US" sz="800" dirty="0"/>
+          </a:p>
+        </p:txBody>
+      </p:sp>
+      <p:sp>
+        <p:nvSpPr>
+          <p:cNvPr id="25" name="Text 23"/>
+          <p:cNvSpPr/>
+          <p:nvPr/>
+        </p:nvSpPr>
+        <p:spPr>
+          <a:xfrm>
+            <a:off x="4297680" y="3127248"/>
+            <a:ext cx="1371600" cy="274320"/>
+          </a:xfrm>
+          <a:prstGeom prst="rect">
+            <a:avLst/>
+          </a:prstGeom>
+          <a:noFill/>
+          <a:ln/>
+        </p:spPr>
+        <p:txBody>
+          <a:bodyPr wrap="square" lIns="0" tIns="0" rIns="0" bIns="0" rtlCol="0" anchor="ctr"/>
+          <a:lstStyle/>
+          <a:p>
+            <a:pPr algn="l" indent="0" marL="0">
+              <a:buNone/>
+            </a:pPr>
+            <a:r>
+              <a:rPr lang="en-US" sz="900" b="1" dirty="0">
+                <a:solidFill>
+                  <a:srgbClr val="FFFFFF"/>
+                </a:solidFill>
+                <a:latin typeface="Arial" pitchFamily="34" charset="0"/>
+                <a:ea typeface="Arial" pitchFamily="34" charset="-122"/>
+                <a:cs typeface="Arial" pitchFamily="34" charset="-120"/>
+              </a:rPr>
+              <a:t>☁️ Re-upload IPFS</a:t>
+            </a:r>
+            <a:endParaRPr lang="en-US" sz="900" dirty="0"/>
+          </a:p>
+        </p:txBody>
+      </p:sp>
+      <p:sp>
+        <p:nvSpPr>
+          <p:cNvPr id="26" name="Text 24"/>
+          <p:cNvSpPr/>
+          <p:nvPr/>
+        </p:nvSpPr>
+        <p:spPr>
+          <a:xfrm>
+            <a:off x="5669280" y="3127248"/>
+            <a:ext cx="1371600" cy="274320"/>
+          </a:xfrm>
+          <a:prstGeom prst="rect">
+            <a:avLst/>
+          </a:prstGeom>
+          <a:noFill/>
+          <a:ln/>
+        </p:spPr>
+        <p:txBody>
+          <a:bodyPr wrap="square" lIns="0" tIns="0" rIns="0" bIns="0" rtlCol="0" anchor="ctr"/>
+          <a:lstStyle/>
+          <a:p>
+            <a:pPr algn="l" indent="0" marL="0">
+              <a:buNone/>
+            </a:pPr>
+            <a:r>
+              <a:rPr lang="en-US" sz="800" dirty="0">
+                <a:solidFill>
+                  <a:srgbClr val="CBD5E1"/>
+                </a:solidFill>
+                <a:latin typeface="Arial" pitchFamily="34" charset="0"/>
+                <a:ea typeface="Arial" pitchFamily="34" charset="-122"/>
+                <a:cs typeface="Arial" pitchFamily="34" charset="-120"/>
+              </a:rPr>
+              <a:t>Redundant storage</a:t>
+            </a:r>
+            <a:endParaRPr lang="en-US" sz="800" dirty="0"/>
+          </a:p>
+        </p:txBody>
+      </p:sp>
+      <p:sp>
+        <p:nvSpPr>
+          <p:cNvPr id="27" name="Text 25"/>
+          <p:cNvSpPr/>
+          <p:nvPr/>
+        </p:nvSpPr>
+        <p:spPr>
+          <a:xfrm>
+            <a:off x="4297680" y="3511296"/>
+            <a:ext cx="1371600" cy="274320"/>
+          </a:xfrm>
+          <a:prstGeom prst="rect">
+            <a:avLst/>
+          </a:prstGeom>
+          <a:noFill/>
+          <a:ln/>
+        </p:spPr>
+        <p:txBody>
+          <a:bodyPr wrap="square" lIns="0" tIns="0" rIns="0" bIns="0" rtlCol="0" anchor="ctr"/>
+          <a:lstStyle/>
+          <a:p>
+            <a:pPr algn="l" indent="0" marL="0">
+              <a:buNone/>
+            </a:pPr>
+            <a:r>
+              <a:rPr lang="en-US" sz="900" b="1" dirty="0">
+                <a:solidFill>
+                  <a:srgbClr val="FFFFFF"/>
+                </a:solidFill>
+                <a:latin typeface="Arial" pitchFamily="34" charset="0"/>
+                <a:ea typeface="Arial" pitchFamily="34" charset="-122"/>
+                <a:cs typeface="Arial" pitchFamily="34" charset="-120"/>
+              </a:rPr>
+              <a:t>🔔 Push Notify</a:t>
+            </a:r>
+            <a:endParaRPr lang="en-US" sz="900" dirty="0"/>
+          </a:p>
+        </p:txBody>
+      </p:sp>
+      <p:sp>
+        <p:nvSpPr>
+          <p:cNvPr id="28" name="Text 26"/>
+          <p:cNvSpPr/>
+          <p:nvPr/>
+        </p:nvSpPr>
+        <p:spPr>
+          <a:xfrm>
+            <a:off x="5669280" y="3511296"/>
+            <a:ext cx="1371600" cy="274320"/>
+          </a:xfrm>
+          <a:prstGeom prst="rect">
+            <a:avLst/>
+          </a:prstGeom>
+          <a:noFill/>
+          <a:ln/>
+        </p:spPr>
+        <p:txBody>
+          <a:bodyPr wrap="square" lIns="0" tIns="0" rIns="0" bIns="0" rtlCol="0" anchor="ctr"/>
+          <a:lstStyle/>
+          <a:p>
+            <a:pPr algn="l" indent="0" marL="0">
+              <a:buNone/>
+            </a:pPr>
+            <a:r>
+              <a:rPr lang="en-US" sz="800" dirty="0">
+                <a:solidFill>
+                  <a:srgbClr val="CBD5E1"/>
+                </a:solidFill>
+                <a:latin typeface="Arial" pitchFamily="34" charset="0"/>
+                <a:ea typeface="Arial" pitchFamily="34" charset="-122"/>
+                <a:cs typeface="Arial" pitchFamily="34" charset="-120"/>
+              </a:rPr>
+              <a:t>Alert contacts</a:t>
+            </a:r>
+            <a:endParaRPr lang="en-US" sz="800" dirty="0"/>
+          </a:p>
+        </p:txBody>
+      </p:sp>
+      <p:sp>
+        <p:nvSpPr>
+          <p:cNvPr id="29" name="Text 27"/>
+          <p:cNvSpPr/>
+          <p:nvPr/>
+        </p:nvSpPr>
+        <p:spPr>
+          <a:xfrm>
+            <a:off x="4297680" y="3895344"/>
+            <a:ext cx="1371600" cy="274320"/>
+          </a:xfrm>
+          <a:prstGeom prst="rect">
+            <a:avLst/>
+          </a:prstGeom>
+          <a:noFill/>
+          <a:ln/>
+        </p:spPr>
+        <p:txBody>
+          <a:bodyPr wrap="square" lIns="0" tIns="0" rIns="0" bIns="0" rtlCol="0" anchor="ctr"/>
+          <a:lstStyle/>
+          <a:p>
+            <a:pPr algn="l" indent="0" marL="0">
+              <a:buNone/>
+            </a:pPr>
+            <a:r>
+              <a:rPr lang="en-US" sz="900" b="1" dirty="0">
+                <a:solidFill>
+                  <a:srgbClr val="FFFFFF"/>
+                </a:solidFill>
+                <a:latin typeface="Arial" pitchFamily="34" charset="0"/>
+                <a:ea typeface="Arial" pitchFamily="34" charset="-122"/>
+                <a:cs typeface="Arial" pitchFamily="34" charset="-120"/>
+              </a:rPr>
+              <a:t>🔑 Key Distribution</a:t>
+            </a:r>
+            <a:endParaRPr lang="en-US" sz="900" dirty="0"/>
+          </a:p>
+        </p:txBody>
+      </p:sp>
+      <p:sp>
+        <p:nvSpPr>
+          <p:cNvPr id="30" name="Text 28"/>
+          <p:cNvSpPr/>
+          <p:nvPr/>
+        </p:nvSpPr>
+        <p:spPr>
+          <a:xfrm>
+            <a:off x="5669280" y="3895344"/>
+            <a:ext cx="1371600" cy="274320"/>
+          </a:xfrm>
+          <a:prstGeom prst="rect">
+            <a:avLst/>
+          </a:prstGeom>
+          <a:noFill/>
+          <a:ln/>
+        </p:spPr>
+        <p:txBody>
+          <a:bodyPr wrap="square" lIns="0" tIns="0" rIns="0" bIns="0" rtlCol="0" anchor="ctr"/>
+          <a:lstStyle/>
+          <a:p>
+            <a:pPr algn="l" indent="0" marL="0">
+              <a:buNone/>
+            </a:pPr>
+            <a:r>
+              <a:rPr lang="en-US" sz="800" dirty="0">
+                <a:solidFill>
+                  <a:srgbClr val="CBD5E1"/>
+                </a:solidFill>
+                <a:latin typeface="Arial" pitchFamily="34" charset="0"/>
+                <a:ea typeface="Arial" pitchFamily="34" charset="-122"/>
+                <a:cs typeface="Arial" pitchFamily="34" charset="-120"/>
+              </a:rPr>
+              <a:t>E2EE key mgmt</a:t>
+            </a:r>
+            <a:endParaRPr lang="en-US" sz="800" dirty="0"/>
+          </a:p>
+        </p:txBody>
+      </p:sp>
+      <p:sp>
+        <p:nvSpPr>
+          <p:cNvPr id="31" name="Shape 29"/>
+          <p:cNvSpPr/>
+          <p:nvPr/>
+        </p:nvSpPr>
+        <p:spPr>
+          <a:xfrm>
+            <a:off x="7406640" y="1234440"/>
+            <a:ext cx="1463040" cy="1463040"/>
+          </a:xfrm>
+          <a:prstGeom prst="rect">
+            <a:avLst/>
+          </a:prstGeom>
+          <a:solidFill>
+            <a:srgbClr val="0052FF"/>
+          </a:solidFill>
+          <a:ln w="12700">
+            <a:solidFill>
+              <a:srgbClr val="0052FF"/>
+            </a:solidFill>
+            <a:prstDash val="solid"/>
+          </a:ln>
+        </p:spPr>
+      </p:sp>
+      <p:sp>
+        <p:nvSpPr>
+          <p:cNvPr id="32" name="Text 30"/>
+          <p:cNvSpPr/>
+          <p:nvPr/>
+        </p:nvSpPr>
+        <p:spPr>
+          <a:xfrm>
+            <a:off x="7406640" y="1371600"/>
+            <a:ext cx="1463040" cy="228600"/>
+          </a:xfrm>
+          <a:prstGeom prst="rect">
+            <a:avLst/>
+          </a:prstGeom>
+          <a:noFill/>
+          <a:ln/>
+        </p:spPr>
+        <p:txBody>
+          <a:bodyPr wrap="square" lIns="0" tIns="0" rIns="0" bIns="0" rtlCol="0" anchor="ctr"/>
+          <a:lstStyle/>
+          <a:p>
+            <a:pPr algn="ctr" indent="0" marL="0">
+              <a:buNone/>
+            </a:pPr>
+            <a:r>
+              <a:rPr lang="en-US" sz="1100" b="1" dirty="0">
+                <a:solidFill>
+                  <a:srgbClr val="FFFFFF"/>
+                </a:solidFill>
+                <a:latin typeface="Arial" pitchFamily="34" charset="0"/>
+                <a:ea typeface="Arial" pitchFamily="34" charset="-122"/>
+                <a:cs typeface="Arial" pitchFamily="34" charset="-120"/>
+              </a:rPr>
+              <a:t>Base</a:t>
+            </a:r>
+            <a:endParaRPr lang="en-US" sz="1100" dirty="0"/>
+          </a:p>
+        </p:txBody>
+      </p:sp>
+      <p:sp>
+        <p:nvSpPr>
+          <p:cNvPr id="33" name="Text 31"/>
+          <p:cNvSpPr/>
+          <p:nvPr/>
+        </p:nvSpPr>
+        <p:spPr>
+          <a:xfrm>
+            <a:off x="7406640" y="1600200"/>
+            <a:ext cx="1463040" cy="228600"/>
+          </a:xfrm>
+          <a:prstGeom prst="rect">
+            <a:avLst/>
+          </a:prstGeom>
+          <a:noFill/>
+          <a:ln/>
+        </p:spPr>
+        <p:txBody>
+          <a:bodyPr wrap="square" lIns="0" tIns="0" rIns="0" bIns="0" rtlCol="0" anchor="ctr"/>
+          <a:lstStyle/>
+          <a:p>
+            <a:pPr algn="ctr" indent="0" marL="0">
+              <a:buNone/>
+            </a:pPr>
+            <a:r>
+              <a:rPr lang="en-US" sz="1100" b="1" dirty="0">
+                <a:solidFill>
+                  <a:srgbClr val="FFFFFF"/>
+                </a:solidFill>
+                <a:latin typeface="Arial" pitchFamily="34" charset="0"/>
+                <a:ea typeface="Arial" pitchFamily="34" charset="-122"/>
+                <a:cs typeface="Arial" pitchFamily="34" charset="-120"/>
+              </a:rPr>
+              <a:t>Sepolia</a:t>
+            </a:r>
+            <a:endParaRPr lang="en-US" sz="1100" dirty="0"/>
+          </a:p>
+        </p:txBody>
+      </p:sp>
+      <p:sp>
+        <p:nvSpPr>
+          <p:cNvPr id="34" name="Text 32"/>
+          <p:cNvSpPr/>
+          <p:nvPr/>
+        </p:nvSpPr>
+        <p:spPr>
+          <a:xfrm>
+            <a:off x="7406640" y="1920240"/>
+            <a:ext cx="1463040" cy="182880"/>
+          </a:xfrm>
+          <a:prstGeom prst="rect">
+            <a:avLst/>
+          </a:prstGeom>
+          <a:noFill/>
+          <a:ln/>
+        </p:spPr>
+        <p:txBody>
+          <a:bodyPr wrap="square" lIns="0" tIns="0" rIns="0" bIns="0" rtlCol="0" anchor="ctr"/>
+          <a:lstStyle/>
+          <a:p>
+            <a:pPr algn="ctr" indent="0" marL="0">
+              <a:buNone/>
+            </a:pPr>
+            <a:r>
+              <a:rPr lang="en-US" sz="800" dirty="0">
+                <a:solidFill>
+                  <a:srgbClr val="CBD5E1"/>
+                </a:solidFill>
+                <a:latin typeface="Arial" pitchFamily="34" charset="0"/>
+                <a:ea typeface="Arial" pitchFamily="34" charset="-122"/>
+                <a:cs typeface="Arial" pitchFamily="34" charset="-120"/>
+              </a:rPr>
+              <a:t>Merkle Root</a:t>
+            </a:r>
+            <a:endParaRPr lang="en-US" sz="800" dirty="0"/>
+          </a:p>
+        </p:txBody>
+      </p:sp>
+      <p:sp>
+        <p:nvSpPr>
+          <p:cNvPr id="35" name="Text 33"/>
+          <p:cNvSpPr/>
+          <p:nvPr/>
+        </p:nvSpPr>
+        <p:spPr>
+          <a:xfrm>
+            <a:off x="7406640" y="2103120"/>
+            <a:ext cx="1463040" cy="182880"/>
+          </a:xfrm>
+          <a:prstGeom prst="rect">
+            <a:avLst/>
+          </a:prstGeom>
+          <a:noFill/>
+          <a:ln/>
+        </p:spPr>
+        <p:txBody>
+          <a:bodyPr wrap="square" lIns="0" tIns="0" rIns="0" bIns="0" rtlCol="0" anchor="ctr"/>
+          <a:lstStyle/>
+          <a:p>
+            <a:pPr algn="ctr" indent="0" marL="0">
+              <a:buNone/>
+            </a:pPr>
+            <a:r>
+              <a:rPr lang="en-US" sz="800" dirty="0">
+                <a:solidFill>
+                  <a:srgbClr val="CBD5E1"/>
+                </a:solidFill>
+                <a:latin typeface="Arial" pitchFamily="34" charset="0"/>
+                <a:ea typeface="Arial" pitchFamily="34" charset="-122"/>
+                <a:cs typeface="Arial" pitchFamily="34" charset="-120"/>
+              </a:rPr>
+              <a:t>Timestamps</a:t>
+            </a:r>
+            <a:endParaRPr lang="en-US" sz="800" dirty="0"/>
+          </a:p>
+        </p:txBody>
+      </p:sp>
+      <p:sp>
+        <p:nvSpPr>
+          <p:cNvPr id="36" name="Text 34"/>
+          <p:cNvSpPr/>
+          <p:nvPr/>
+        </p:nvSpPr>
+        <p:spPr>
+          <a:xfrm>
+            <a:off x="7406640" y="2286000"/>
+            <a:ext cx="1463040" cy="182880"/>
+          </a:xfrm>
+          <a:prstGeom prst="rect">
+            <a:avLst/>
+          </a:prstGeom>
+          <a:noFill/>
+          <a:ln/>
+        </p:spPr>
+        <p:txBody>
+          <a:bodyPr wrap="square" lIns="0" tIns="0" rIns="0" bIns="0" rtlCol="0" anchor="ctr"/>
+          <a:lstStyle/>
+          <a:p>
+            <a:pPr algn="ctr" indent="0" marL="0">
+              <a:buNone/>
+            </a:pPr>
+            <a:r>
+              <a:rPr lang="en-US" sz="800" dirty="0">
+                <a:solidFill>
+                  <a:srgbClr val="CBD5E1"/>
+                </a:solidFill>
+                <a:latin typeface="Arial" pitchFamily="34" charset="0"/>
+                <a:ea typeface="Arial" pitchFamily="34" charset="-122"/>
+                <a:cs typeface="Arial" pitchFamily="34" charset="-120"/>
+              </a:rPr>
+              <a:t>Attestations</a:t>
+            </a:r>
+            <a:endParaRPr lang="en-US" sz="800" dirty="0"/>
+          </a:p>
+        </p:txBody>
+      </p:sp>
+      <p:sp>
+        <p:nvSpPr>
+          <p:cNvPr id="37" name="Text 35"/>
+          <p:cNvSpPr/>
+          <p:nvPr/>
+        </p:nvSpPr>
+        <p:spPr>
+          <a:xfrm>
+            <a:off x="5669280" y="1417320"/>
+            <a:ext cx="457200" cy="365760"/>
+          </a:xfrm>
+          <a:prstGeom prst="rect">
+            <a:avLst/>
+          </a:prstGeom>
+          <a:noFill/>
+          <a:ln/>
+        </p:spPr>
+        <p:txBody>
+          <a:bodyPr wrap="square" lIns="0" tIns="0" rIns="0" bIns="0" rtlCol="0" anchor="ctr"/>
+          <a:lstStyle/>
+          <a:p>
+            <a:pPr algn="ctr" indent="0" marL="0">
+              <a:buNone/>
+            </a:pPr>
+            <a:r>
+              <a:rPr lang="en-US" sz="1800" dirty="0">
+                <a:solidFill>
+                  <a:srgbClr val="06B6D4"/>
+                </a:solidFill>
+                <a:latin typeface="Arial" pitchFamily="34" charset="0"/>
+                <a:ea typeface="Arial" pitchFamily="34" charset="-122"/>
+                <a:cs typeface="Arial" pitchFamily="34" charset="-120"/>
+              </a:rPr>
+              <a:t>→</a:t>
+            </a:r>
+            <a:endParaRPr lang="en-US" sz="1800" dirty="0"/>
+          </a:p>
+        </p:txBody>
+      </p:sp>
+      <p:sp>
+        <p:nvSpPr>
+          <p:cNvPr id="38" name="Text 36"/>
+          <p:cNvSpPr/>
+          <p:nvPr/>
+        </p:nvSpPr>
+        <p:spPr>
+          <a:xfrm>
+            <a:off x="7086600" y="2926080"/>
+            <a:ext cx="457200" cy="365760"/>
+          </a:xfrm>
+          <a:prstGeom prst="rect">
+            <a:avLst/>
+          </a:prstGeom>
+          <a:noFill/>
+          <a:ln/>
+        </p:spPr>
+        <p:txBody>
+          <a:bodyPr wrap="square" lIns="0" tIns="0" rIns="0" bIns="0" rtlCol="0" anchor="ctr"/>
+          <a:lstStyle/>
+          <a:p>
+            <a:pPr algn="ctr" indent="0" marL="0">
+              <a:buNone/>
+            </a:pPr>
+            <a:r>
+              <a:rPr lang="en-US" sz="1800" dirty="0">
+                <a:solidFill>
+                  <a:srgbClr val="A78BFA"/>
+                </a:solidFill>
+                <a:latin typeface="Arial" pitchFamily="34" charset="0"/>
+                <a:ea typeface="Arial" pitchFamily="34" charset="-122"/>
+                <a:cs typeface="Arial" pitchFamily="34" charset="-120"/>
+              </a:rPr>
+              <a:t>→</a:t>
+            </a:r>
+            <a:endParaRPr lang="en-US" sz="1800" dirty="0"/>
+          </a:p>
+        </p:txBody>
+      </p:sp>
+      <p:sp>
+        <p:nvSpPr>
+          <p:cNvPr id="39" name="Shape 37"/>
+          <p:cNvSpPr/>
+          <p:nvPr/>
+        </p:nvSpPr>
+        <p:spPr>
+          <a:xfrm>
+            <a:off x="274320" y="3200400"/>
+            <a:ext cx="2560320" cy="1234440"/>
+          </a:xfrm>
+          <a:prstGeom prst="rect">
+            <a:avLst/>
+          </a:prstGeom>
+          <a:solidFill>
+            <a:srgbClr val="1E293B"/>
+          </a:solidFill>
+          <a:ln w="25400">
+            <a:solidFill>
+              <a:srgbClr val="06B6D4"/>
+            </a:solidFill>
+            <a:prstDash val="solid"/>
+          </a:ln>
+        </p:spPr>
+      </p:sp>
+      <p:sp>
+        <p:nvSpPr>
+          <p:cNvPr id="40" name="Text 38"/>
+          <p:cNvSpPr/>
+          <p:nvPr/>
+        </p:nvSpPr>
+        <p:spPr>
+          <a:xfrm>
+            <a:off x="365760" y="3246120"/>
+            <a:ext cx="2377440" cy="274320"/>
+          </a:xfrm>
+          <a:prstGeom prst="rect">
+            <a:avLst/>
+          </a:prstGeom>
+          <a:noFill/>
+          <a:ln/>
+        </p:spPr>
+        <p:txBody>
+          <a:bodyPr wrap="square" lIns="0" tIns="0" rIns="0" bIns="0" rtlCol="0" anchor="ctr"/>
+          <a:lstStyle/>
+          <a:p>
+            <a:pPr algn="l" indent="0" marL="0">
+              <a:buNone/>
+            </a:pPr>
+            <a:r>
+              <a:rPr lang="en-US" sz="1100" b="1" dirty="0">
+                <a:solidFill>
+                  <a:srgbClr val="06B6D4"/>
+                </a:solidFill>
+                <a:latin typeface="Arial" pitchFamily="34" charset="0"/>
+                <a:ea typeface="Arial" pitchFamily="34" charset="-122"/>
+                <a:cs typeface="Arial" pitchFamily="34" charset="-120"/>
+              </a:rPr>
+              <a:t>👥 Trusted Contacts</a:t>
+            </a:r>
+            <a:endParaRPr lang="en-US" sz="1100" dirty="0"/>
+          </a:p>
+        </p:txBody>
+      </p:sp>
+      <p:sp>
+        <p:nvSpPr>
+          <p:cNvPr id="41" name="Text 39"/>
+          <p:cNvSpPr/>
+          <p:nvPr/>
+        </p:nvSpPr>
+        <p:spPr>
+          <a:xfrm>
+            <a:off x="457200" y="3566160"/>
+            <a:ext cx="2286000" cy="228600"/>
+          </a:xfrm>
+          <a:prstGeom prst="rect">
+            <a:avLst/>
+          </a:prstGeom>
+          <a:noFill/>
+          <a:ln/>
+        </p:spPr>
+        <p:txBody>
+          <a:bodyPr wrap="square" lIns="0" tIns="0" rIns="0" bIns="0" rtlCol="0" anchor="ctr"/>
+          <a:lstStyle/>
+          <a:p>
+            <a:pPr algn="l" indent="0" marL="0">
+              <a:buNone/>
+            </a:pPr>
+            <a:r>
+              <a:rPr lang="en-US" sz="900" dirty="0">
+                <a:solidFill>
+                  <a:srgbClr val="CBD5E1"/>
+                </a:solidFill>
+                <a:latin typeface="Arial" pitchFamily="34" charset="0"/>
+                <a:ea typeface="Arial" pitchFamily="34" charset="-122"/>
+                <a:cs typeface="Arial" pitchFamily="34" charset="-120"/>
+              </a:rPr>
+              <a:t>• Real-time notifications</a:t>
+            </a:r>
+            <a:endParaRPr lang="en-US" sz="900" dirty="0"/>
+          </a:p>
+        </p:txBody>
+      </p:sp>
+      <p:sp>
+        <p:nvSpPr>
+          <p:cNvPr id="42" name="Text 40"/>
+          <p:cNvSpPr/>
+          <p:nvPr/>
+        </p:nvSpPr>
+        <p:spPr>
+          <a:xfrm>
+            <a:off x="457200" y="3822192"/>
+            <a:ext cx="2286000" cy="228600"/>
+          </a:xfrm>
+          <a:prstGeom prst="rect">
+            <a:avLst/>
+          </a:prstGeom>
+          <a:noFill/>
+          <a:ln/>
+        </p:spPr>
+        <p:txBody>
+          <a:bodyPr wrap="square" lIns="0" tIns="0" rIns="0" bIns="0" rtlCol="0" anchor="ctr"/>
+          <a:lstStyle/>
+          <a:p>
+            <a:pPr algn="l" indent="0" marL="0">
+              <a:buNone/>
+            </a:pPr>
+            <a:r>
+              <a:rPr lang="en-US" sz="900" dirty="0">
+                <a:solidFill>
+                  <a:srgbClr val="CBD5E1"/>
+                </a:solidFill>
+                <a:latin typeface="Arial" pitchFamily="34" charset="0"/>
+                <a:ea typeface="Arial" pitchFamily="34" charset="-122"/>
+                <a:cs typeface="Arial" pitchFamily="34" charset="-120"/>
+              </a:rPr>
+              <a:t>• Auto key sync via Matrix</a:t>
+            </a:r>
+            <a:endParaRPr lang="en-US" sz="900" dirty="0"/>
+          </a:p>
+        </p:txBody>
+      </p:sp>
+      <p:sp>
+        <p:nvSpPr>
+          <p:cNvPr id="43" name="Text 41"/>
+          <p:cNvSpPr/>
+          <p:nvPr/>
+        </p:nvSpPr>
+        <p:spPr>
+          <a:xfrm>
+            <a:off x="457200" y="4078224"/>
+            <a:ext cx="2286000" cy="228600"/>
+          </a:xfrm>
+          <a:prstGeom prst="rect">
+            <a:avLst/>
+          </a:prstGeom>
+          <a:noFill/>
+          <a:ln/>
+        </p:spPr>
+        <p:txBody>
+          <a:bodyPr wrap="square" lIns="0" tIns="0" rIns="0" bIns="0" rtlCol="0" anchor="ctr"/>
+          <a:lstStyle/>
+          <a:p>
+            <a:pPr algn="l" indent="0" marL="0">
+              <a:buNone/>
+            </a:pPr>
+            <a:r>
+              <a:rPr lang="en-US" sz="900" dirty="0">
+                <a:solidFill>
+                  <a:srgbClr val="CBD5E1"/>
+                </a:solidFill>
+                <a:latin typeface="Arial" pitchFamily="34" charset="0"/>
+                <a:ea typeface="Arial" pitchFamily="34" charset="-122"/>
+                <a:cs typeface="Arial" pitchFamily="34" charset="-120"/>
+              </a:rPr>
+              <a:t>• Decrypt + View + Attest</a:t>
+            </a:r>
+            <a:endParaRPr lang="en-US" sz="900" dirty="0"/>
+          </a:p>
+        </p:txBody>
+      </p:sp>
+      <p:sp>
+        <p:nvSpPr>
+          <p:cNvPr id="44" name="Shape 42"/>
+          <p:cNvSpPr/>
+          <p:nvPr/>
+        </p:nvSpPr>
+        <p:spPr>
+          <a:xfrm>
+            <a:off x="4160520" y="3840480"/>
+            <a:ext cx="-1371600" cy="0"/>
+          </a:xfrm>
+          <a:prstGeom prst="line">
+            <a:avLst/>
+          </a:prstGeom>
+          <a:noFill/>
+          <a:ln w="25400">
+            <a:solidFill>
+              <a:srgbClr val="A78BFA"/>
+            </a:solidFill>
+            <a:prstDash val="dash"/>
+          </a:ln>
+        </p:spPr>
+      </p:sp>
+      <p:sp>
+        <p:nvSpPr>
+          <p:cNvPr id="45" name="Text 43"/>
+          <p:cNvSpPr/>
+          <p:nvPr/>
+        </p:nvSpPr>
+        <p:spPr>
+          <a:xfrm>
+            <a:off x="3017520" y="3611880"/>
+            <a:ext cx="914400" cy="228600"/>
+          </a:xfrm>
+          <a:prstGeom prst="rect">
+            <a:avLst/>
+          </a:prstGeom>
+          <a:noFill/>
+          <a:ln/>
+        </p:spPr>
+        <p:txBody>
+          <a:bodyPr wrap="square" lIns="0" tIns="0" rIns="0" bIns="0" rtlCol="0" anchor="ctr"/>
+          <a:lstStyle/>
+          <a:p>
+            <a:pPr algn="ctr" indent="0" marL="0">
+              <a:buNone/>
+            </a:pPr>
+            <a:r>
+              <a:rPr lang="en-US" sz="800" dirty="0">
+                <a:solidFill>
+                  <a:srgbClr val="A78BFA"/>
+                </a:solidFill>
+                <a:latin typeface="Arial" pitchFamily="34" charset="0"/>
+                <a:ea typeface="Arial" pitchFamily="34" charset="-122"/>
+                <a:cs typeface="Arial" pitchFamily="34" charset="-120"/>
+              </a:rPr>
+              <a:t>notify</a:t>
+            </a:r>
+            <a:endParaRPr lang="en-US" sz="800" dirty="0"/>
+          </a:p>
+        </p:txBody>
+      </p:sp>
+      <p:sp>
+        <p:nvSpPr>
+          <p:cNvPr id="46" name="Shape 44"/>
+          <p:cNvSpPr/>
+          <p:nvPr/>
+        </p:nvSpPr>
+        <p:spPr>
+          <a:xfrm>
+            <a:off x="7406640" y="3200400"/>
+            <a:ext cx="1463040" cy="914400"/>
+          </a:xfrm>
+          <a:prstGeom prst="rect">
+            <a:avLst/>
+          </a:prstGeom>
+          <a:solidFill>
+            <a:srgbClr val="059669"/>
+          </a:solidFill>
+          <a:ln w="12700">
+            <a:solidFill>
+              <a:srgbClr val="059669"/>
+            </a:solidFill>
+            <a:prstDash val="solid"/>
+          </a:ln>
+        </p:spPr>
+      </p:sp>
+      <p:sp>
+        <p:nvSpPr>
+          <p:cNvPr id="47" name="Text 45"/>
+          <p:cNvSpPr/>
+          <p:nvPr/>
+        </p:nvSpPr>
+        <p:spPr>
+          <a:xfrm>
+            <a:off x="7406640" y="3291840"/>
+            <a:ext cx="1463040" cy="228600"/>
+          </a:xfrm>
+          <a:prstGeom prst="rect">
+            <a:avLst/>
+          </a:prstGeom>
+          <a:noFill/>
+          <a:ln/>
+        </p:spPr>
+        <p:txBody>
+          <a:bodyPr wrap="square" lIns="0" tIns="0" rIns="0" bIns="0" rtlCol="0" anchor="ctr"/>
+          <a:lstStyle/>
+          <a:p>
+            <a:pPr algn="ctr" indent="0" marL="0">
+              <a:buNone/>
+            </a:pPr>
+            <a:r>
+              <a:rPr lang="en-US" sz="1000" b="1" dirty="0">
+                <a:solidFill>
+                  <a:srgbClr val="FFFFFF"/>
+                </a:solidFill>
+                <a:latin typeface="Arial" pitchFamily="34" charset="0"/>
+                <a:ea typeface="Arial" pitchFamily="34" charset="-122"/>
+                <a:cs typeface="Arial" pitchFamily="34" charset="-120"/>
+              </a:rPr>
+              <a:t>Semaphore</a:t>
+            </a:r>
+            <a:endParaRPr lang="en-US" sz="1000" dirty="0"/>
+          </a:p>
+        </p:txBody>
+      </p:sp>
+      <p:sp>
+        <p:nvSpPr>
+          <p:cNvPr id="48" name="Text 46"/>
+          <p:cNvSpPr/>
+          <p:nvPr/>
+        </p:nvSpPr>
+        <p:spPr>
+          <a:xfrm>
+            <a:off x="7406640" y="3520440"/>
+            <a:ext cx="1463040" cy="182880"/>
+          </a:xfrm>
+          <a:prstGeom prst="rect">
+            <a:avLst/>
+          </a:prstGeom>
+          <a:noFill/>
+          <a:ln/>
+        </p:spPr>
+        <p:txBody>
+          <a:bodyPr wrap="square" lIns="0" tIns="0" rIns="0" bIns="0" rtlCol="0" anchor="ctr"/>
+          <a:lstStyle/>
+          <a:p>
+            <a:pPr algn="ctr" indent="0" marL="0">
+              <a:buNone/>
+            </a:pPr>
+            <a:r>
+              <a:rPr lang="en-US" sz="800" dirty="0">
+                <a:solidFill>
+                  <a:srgbClr val="CBD5E1"/>
+                </a:solidFill>
+                <a:latin typeface="Arial" pitchFamily="34" charset="0"/>
+                <a:ea typeface="Arial" pitchFamily="34" charset="-122"/>
+                <a:cs typeface="Arial" pitchFamily="34" charset="-120"/>
+              </a:rPr>
+              <a:t>ZK Attestations</a:t>
+            </a:r>
+            <a:endParaRPr lang="en-US" sz="800" dirty="0"/>
+          </a:p>
+        </p:txBody>
+      </p:sp>
+      <p:sp>
+        <p:nvSpPr>
+          <p:cNvPr id="49" name="Text 47"/>
+          <p:cNvSpPr/>
+          <p:nvPr/>
+        </p:nvSpPr>
+        <p:spPr>
+          <a:xfrm>
+            <a:off x="7406640" y="3703320"/>
+            <a:ext cx="1463040" cy="182880"/>
+          </a:xfrm>
+          <a:prstGeom prst="rect">
+            <a:avLst/>
+          </a:prstGeom>
+          <a:noFill/>
+          <a:ln/>
+        </p:spPr>
+        <p:txBody>
+          <a:bodyPr wrap="square" lIns="0" tIns="0" rIns="0" bIns="0" rtlCol="0" anchor="ctr"/>
+          <a:lstStyle/>
+          <a:p>
+            <a:pPr algn="ctr" indent="0" marL="0">
+              <a:buNone/>
+            </a:pPr>
+            <a:r>
+              <a:rPr lang="en-US" sz="800" dirty="0">
+                <a:solidFill>
+                  <a:srgbClr val="CBD5E1"/>
+                </a:solidFill>
+                <a:latin typeface="Arial" pitchFamily="34" charset="0"/>
+                <a:ea typeface="Arial" pitchFamily="34" charset="-122"/>
+                <a:cs typeface="Arial" pitchFamily="34" charset="-120"/>
+              </a:rPr>
+              <a:t>Anonymous Count</a:t>
+            </a:r>
+            <a:endParaRPr lang="en-US" sz="800" dirty="0"/>
+          </a:p>
+        </p:txBody>
+      </p:sp>
+      <p:sp>
+        <p:nvSpPr>
+          <p:cNvPr id="50" name="Shape 48"/>
+          <p:cNvSpPr/>
+          <p:nvPr/>
+        </p:nvSpPr>
+        <p:spPr>
+          <a:xfrm>
+            <a:off x="274320" y="4572000"/>
+            <a:ext cx="8595360" cy="411480"/>
+          </a:xfrm>
+          <a:prstGeom prst="rect">
+            <a:avLst/>
+          </a:prstGeom>
+          <a:solidFill>
+            <a:srgbClr val="7C3AED">
+              <a:alpha val="30000"/>
+            </a:srgbClr>
+          </a:solidFill>
+          <a:ln w="12700">
+            <a:solidFill>
+              <a:srgbClr val="7C3AED"/>
+            </a:solidFill>
+            <a:prstDash val="solid"/>
+          </a:ln>
+        </p:spPr>
+      </p:sp>
+      <p:sp>
+        <p:nvSpPr>
+          <p:cNvPr id="51" name="Text 49"/>
+          <p:cNvSpPr/>
+          <p:nvPr/>
+        </p:nvSpPr>
+        <p:spPr>
+          <a:xfrm>
+            <a:off x="365760" y="4617720"/>
+            <a:ext cx="8412480" cy="320040"/>
+          </a:xfrm>
+          <a:prstGeom prst="rect">
+            <a:avLst/>
+          </a:prstGeom>
+          <a:noFill/>
+          <a:ln/>
+        </p:spPr>
+        <p:txBody>
+          <a:bodyPr wrap="square" lIns="0" tIns="0" rIns="0" bIns="0" rtlCol="0" anchor="ctr"/>
+          <a:lstStyle/>
+          <a:p>
+            <a:pPr algn="ctr" indent="0" marL="0">
+              <a:buNone/>
+            </a:pPr>
+            <a:r>
+              <a:rPr lang="en-US" sz="1000" dirty="0">
+                <a:solidFill>
+                  <a:srgbClr val="FFFFFF"/>
+                </a:solidFill>
+                <a:latin typeface="Arial" pitchFamily="34" charset="0"/>
+                <a:ea typeface="Arial" pitchFamily="34" charset="-122"/>
+                <a:cs typeface="Arial" pitchFamily="34" charset="-120"/>
+              </a:rPr>
+              <a:t>💡 zkTLS proves video came from phone camera, not AI-generated • Matrix enables instant notifications + key management</a:t>
+            </a:r>
+            <a:endParaRPr lang="en-US" sz="1000" dirty="0"/>
+          </a:p>
+        </p:txBody>
+      </p:sp>
+    </p:spTree>
+  </p:cSld>
+  <p:clrMapOvr>
+    <a:masterClrMapping/>
+  </p:clrMapOvr>
+</p:sld>
+</file>
+
 <file path=ppt/theme/theme1.xml><?xml version="1.0" encoding="utf-8"?>
 <a:theme xmlns:a="http://schemas.openxmlformats.org/drawingml/2006/main" name="Office Theme">
   <a:themeElements>

</xml_diff>